<commit_message>
Acrescenta slide de FIDC ao deck do ranking ANBIMA
O recorte de FIDC era o que o presidente pediu especificamente e aparecia
apenas como uma linha na tabela de subdivisões. Ganha slide próprio: volume
originado, participação, posição, número de operações, ranking dos onze
coordenadores ativos e a ponte com o universo da CVM.

A contagem de operações por participante não soma o total do bloco, porque
uma operação sindicalizada credita uma unidade a cada coordenador. O total
vem do anexo, deduplicado por operação, e não da soma da coluna.

Atualiza a documentação, que ainda descrevia o deck como pendente.

Co-Authored-By: Claude Opus 5 <noreply@anthropic.com>
Claude-Session: https://claude.ai/code/session_01FrhRehJE46Q9y75Np8uTt8
</commit_message>
<xml_diff>
--- a/outputs/anbima_ranking_rf_presidente/ANBIMA_Ranking_Renda_Fixa_Itau_BBA_1S26.pptx
+++ b/outputs/anbima_ranking_rf_presidente/ANBIMA_Ranking_Renda_Fixa_Itau_BBA_1S26.pptx
@@ -10,6 +10,7 @@
     <p:sldId id="258" r:id="rId9"/>
     <p:sldId id="259" r:id="rId10"/>
     <p:sldId id="260" r:id="rId11"/>
+    <p:sldId id="261" r:id="rId12"/>
   </p:sldIdLst>
   <p:sldSz cx="12191695" cy="6858000" type="screen4x3"/>
   <p:notesSz cx="6858000" cy="9144000"/>
@@ -8272,7 +8273,7 @@
               </a:defRPr>
             </a:pPr>
             <a:r>
-              <a:t>Como a ANBIMA apura o ranking</a:t>
+              <a:t>Em FIDC o Itaú BBA lidera com 45,7%, mais que o dobro do segundo colocado</a:t>
             </a:r>
           </a:p>
         </p:txBody>
@@ -8328,14 +8329,14 @@
         </p:nvSpPr>
         <p:spPr>
           <a:xfrm>
-            <a:off x="566928" y="1371600"/>
-            <a:ext cx="41148" cy="969264"/>
+            <a:off x="566928" y="1325880"/>
+            <a:ext cx="2615184" cy="1060704"/>
           </a:xfrm>
           <a:prstGeom prst="rect">
             <a:avLst/>
           </a:prstGeom>
           <a:solidFill>
-            <a:srgbClr val="E36C0A"/>
+            <a:srgbClr val="F5F6F7"/>
           </a:solidFill>
           <a:ln>
             <a:noFill/>
@@ -8372,8 +8373,8 @@
         </p:nvSpPr>
         <p:spPr>
           <a:xfrm>
-            <a:off x="822960" y="1371600"/>
-            <a:ext cx="5029200" cy="457200"/>
+            <a:off x="749808" y="1463040"/>
+            <a:ext cx="2286000" cy="201168"/>
           </a:xfrm>
           <a:prstGeom prst="rect">
             <a:avLst/>
@@ -8387,7 +8388,43 @@
           <a:lstStyle/>
           <a:p>
             <a:pPr algn="l">
-              <a:defRPr sz="1300" b="1">
+              <a:defRPr sz="900" b="1">
+                <a:solidFill>
+                  <a:srgbClr val="8D9399"/>
+                </a:solidFill>
+                <a:latin typeface="Arial"/>
+              </a:defRPr>
+            </a:pPr>
+            <a:r>
+              <a:t>VOLUME ORIGINADO</a:t>
+            </a:r>
+          </a:p>
+        </p:txBody>
+      </p:sp>
+      <p:sp>
+        <p:nvSpPr>
+          <p:cNvPr id="7" name="TextBox 6"/>
+          <p:cNvSpPr txBox="1"/>
+          <p:nvPr/>
+        </p:nvSpPr>
+        <p:spPr>
+          <a:xfrm>
+            <a:off x="749808" y="1700784"/>
+            <a:ext cx="2286000" cy="384048"/>
+          </a:xfrm>
+          <a:prstGeom prst="rect">
+            <a:avLst/>
+          </a:prstGeom>
+          <a:noFill/>
+        </p:spPr>
+        <p:txBody>
+          <a:bodyPr wrap="square" anchor="t" lIns="0" rIns="0" tIns="0" bIns="0">
+            <a:spAutoFit/>
+          </a:bodyPr>
+          <a:lstStyle/>
+          <a:p>
+            <a:pPr algn="l">
+              <a:defRPr sz="2000" b="1">
                 <a:solidFill>
                   <a:srgbClr val="151515"/>
                 </a:solidFill>
@@ -8395,21 +8432,21 @@
               </a:defRPr>
             </a:pPr>
             <a:r>
-              <a:t>O ranking credita todos os coordenadores, não só o líder</a:t>
-            </a:r>
-          </a:p>
-        </p:txBody>
-      </p:sp>
-      <p:sp>
-        <p:nvSpPr>
-          <p:cNvPr id="7" name="TextBox 6"/>
-          <p:cNvSpPr txBox="1"/>
-          <p:nvPr/>
-        </p:nvSpPr>
-        <p:spPr>
-          <a:xfrm>
-            <a:off x="822960" y="1792224"/>
-            <a:ext cx="5029200" cy="868680"/>
+              <a:t>R$ 11,4 bi</a:t>
+            </a:r>
+          </a:p>
+        </p:txBody>
+      </p:sp>
+      <p:sp>
+        <p:nvSpPr>
+          <p:cNvPr id="8" name="TextBox 7"/>
+          <p:cNvSpPr txBox="1"/>
+          <p:nvPr/>
+        </p:nvSpPr>
+        <p:spPr>
+          <a:xfrm>
+            <a:off x="749808" y="2103120"/>
+            <a:ext cx="2286000" cy="201168"/>
           </a:xfrm>
           <a:prstGeom prst="rect">
             <a:avLst/>
@@ -8423,35 +8460,35 @@
           <a:lstStyle/>
           <a:p>
             <a:pPr algn="l">
-              <a:defRPr sz="1100" b="0">
-                <a:solidFill>
-                  <a:srgbClr val="5D6369"/>
-                </a:solidFill>
-                <a:latin typeface="Arial"/>
-              </a:defRPr>
-            </a:pPr>
-            <a:r>
-              <a:t>Cada coordenador e coordenador contratado recebe a fatia que lhe cabe na operação. O líder apenas reporta a operação à ANBIMA.</a:t>
-            </a:r>
-          </a:p>
-        </p:txBody>
-      </p:sp>
-      <p:sp>
-        <p:nvSpPr>
-          <p:cNvPr id="8" name="Rectangle 7"/>
+              <a:defRPr sz="900" b="0">
+                <a:solidFill>
+                  <a:srgbClr val="8D9399"/>
+                </a:solidFill>
+                <a:latin typeface="Arial"/>
+              </a:defRPr>
+            </a:pPr>
+            <a:r>
+              <a:t>1S26</a:t>
+            </a:r>
+          </a:p>
+        </p:txBody>
+      </p:sp>
+      <p:sp>
+        <p:nvSpPr>
+          <p:cNvPr id="9" name="Rectangle 8"/>
           <p:cNvSpPr/>
           <p:nvPr/>
         </p:nvSpPr>
         <p:spPr>
           <a:xfrm>
-            <a:off x="6236208" y="1371600"/>
-            <a:ext cx="41148" cy="969264"/>
+            <a:off x="3364992" y="1325880"/>
+            <a:ext cx="2615184" cy="1060704"/>
           </a:xfrm>
           <a:prstGeom prst="rect">
             <a:avLst/>
           </a:prstGeom>
           <a:solidFill>
-            <a:srgbClr val="E36C0A"/>
+            <a:srgbClr val="F5F6F7"/>
           </a:solidFill>
           <a:ln>
             <a:noFill/>
@@ -8482,14 +8519,14 @@
       </p:sp>
       <p:sp>
         <p:nvSpPr>
-          <p:cNvPr id="9" name="TextBox 8"/>
-          <p:cNvSpPr txBox="1"/>
-          <p:nvPr/>
-        </p:nvSpPr>
-        <p:spPr>
-          <a:xfrm>
-            <a:off x="6492240" y="1371600"/>
-            <a:ext cx="5029200" cy="457200"/>
+          <p:cNvPr id="10" name="TextBox 9"/>
+          <p:cNvSpPr txBox="1"/>
+          <p:nvPr/>
+        </p:nvSpPr>
+        <p:spPr>
+          <a:xfrm>
+            <a:off x="3547872" y="1463040"/>
+            <a:ext cx="2286000" cy="201168"/>
           </a:xfrm>
           <a:prstGeom prst="rect">
             <a:avLst/>
@@ -8503,7 +8540,43 @@
           <a:lstStyle/>
           <a:p>
             <a:pPr algn="l">
-              <a:defRPr sz="1300" b="1">
+              <a:defRPr sz="900" b="1">
+                <a:solidFill>
+                  <a:srgbClr val="8D9399"/>
+                </a:solidFill>
+                <a:latin typeface="Arial"/>
+              </a:defRPr>
+            </a:pPr>
+            <a:r>
+              <a:t>PARTICIPAÇÃO</a:t>
+            </a:r>
+          </a:p>
+        </p:txBody>
+      </p:sp>
+      <p:sp>
+        <p:nvSpPr>
+          <p:cNvPr id="11" name="TextBox 10"/>
+          <p:cNvSpPr txBox="1"/>
+          <p:nvPr/>
+        </p:nvSpPr>
+        <p:spPr>
+          <a:xfrm>
+            <a:off x="3547872" y="1700784"/>
+            <a:ext cx="2286000" cy="384048"/>
+          </a:xfrm>
+          <a:prstGeom prst="rect">
+            <a:avLst/>
+          </a:prstGeom>
+          <a:noFill/>
+        </p:spPr>
+        <p:txBody>
+          <a:bodyPr wrap="square" anchor="t" lIns="0" rIns="0" tIns="0" bIns="0">
+            <a:spAutoFit/>
+          </a:bodyPr>
+          <a:lstStyle/>
+          <a:p>
+            <a:pPr algn="l">
+              <a:defRPr sz="2000" b="1">
                 <a:solidFill>
                   <a:srgbClr val="151515"/>
                 </a:solidFill>
@@ -8511,21 +8584,21 @@
               </a:defRPr>
             </a:pPr>
             <a:r>
-              <a:t>O rateio é contratual</a:t>
-            </a:r>
-          </a:p>
-        </p:txBody>
-      </p:sp>
-      <p:sp>
-        <p:nvSpPr>
-          <p:cNvPr id="10" name="TextBox 9"/>
-          <p:cNvSpPr txBox="1"/>
-          <p:nvPr/>
-        </p:nvSpPr>
-        <p:spPr>
-          <a:xfrm>
-            <a:off x="6492240" y="1792224"/>
-            <a:ext cx="5029200" cy="868680"/>
+              <a:t>45,7%</a:t>
+            </a:r>
+          </a:p>
+        </p:txBody>
+      </p:sp>
+      <p:sp>
+        <p:nvSpPr>
+          <p:cNvPr id="12" name="TextBox 11"/>
+          <p:cNvSpPr txBox="1"/>
+          <p:nvPr/>
+        </p:nvSpPr>
+        <p:spPr>
+          <a:xfrm>
+            <a:off x="3547872" y="2103120"/>
+            <a:ext cx="2286000" cy="201168"/>
           </a:xfrm>
           <a:prstGeom prst="rect">
             <a:avLst/>
@@ -8539,35 +8612,35 @@
           <a:lstStyle/>
           <a:p>
             <a:pPr algn="l">
-              <a:defRPr sz="1100" b="0">
-                <a:solidFill>
-                  <a:srgbClr val="5D6369"/>
-                </a:solidFill>
-                <a:latin typeface="Arial"/>
-              </a:defRPr>
-            </a:pPr>
-            <a:r>
-              <a:t>Garantia firme: proporção da garantia definida em contrato. Melhores esforços: proporção do fee de coordenação e/ou estruturação.</a:t>
-            </a:r>
-          </a:p>
-        </p:txBody>
-      </p:sp>
-      <p:sp>
-        <p:nvSpPr>
-          <p:cNvPr id="11" name="Rectangle 10"/>
+              <a:defRPr sz="900" b="0">
+                <a:solidFill>
+                  <a:srgbClr val="8D9399"/>
+                </a:solidFill>
+                <a:latin typeface="Arial"/>
+              </a:defRPr>
+            </a:pPr>
+            <a:r>
+              <a:t>do mercado apurado</a:t>
+            </a:r>
+          </a:p>
+        </p:txBody>
+      </p:sp>
+      <p:sp>
+        <p:nvSpPr>
+          <p:cNvPr id="13" name="Rectangle 12"/>
           <p:cNvSpPr/>
           <p:nvPr/>
         </p:nvSpPr>
         <p:spPr>
           <a:xfrm>
-            <a:off x="566928" y="2944368"/>
-            <a:ext cx="41148" cy="969264"/>
+            <a:off x="6163056" y="1325880"/>
+            <a:ext cx="2615184" cy="1060704"/>
           </a:xfrm>
           <a:prstGeom prst="rect">
             <a:avLst/>
           </a:prstGeom>
           <a:solidFill>
-            <a:srgbClr val="E36C0A"/>
+            <a:srgbClr val="F5F6F7"/>
           </a:solidFill>
           <a:ln>
             <a:noFill/>
@@ -8598,14 +8671,14 @@
       </p:sp>
       <p:sp>
         <p:nvSpPr>
-          <p:cNvPr id="12" name="TextBox 11"/>
-          <p:cNvSpPr txBox="1"/>
-          <p:nvPr/>
-        </p:nvSpPr>
-        <p:spPr>
-          <a:xfrm>
-            <a:off x="822960" y="2944368"/>
-            <a:ext cx="5029200" cy="457200"/>
+          <p:cNvPr id="14" name="TextBox 13"/>
+          <p:cNvSpPr txBox="1"/>
+          <p:nvPr/>
+        </p:nvSpPr>
+        <p:spPr>
+          <a:xfrm>
+            <a:off x="6345936" y="1463040"/>
+            <a:ext cx="2286000" cy="201168"/>
           </a:xfrm>
           <a:prstGeom prst="rect">
             <a:avLst/>
@@ -8619,7 +8692,43 @@
           <a:lstStyle/>
           <a:p>
             <a:pPr algn="l">
-              <a:defRPr sz="1300" b="1">
+              <a:defRPr sz="900" b="1">
+                <a:solidFill>
+                  <a:srgbClr val="8D9399"/>
+                </a:solidFill>
+                <a:latin typeface="Arial"/>
+              </a:defRPr>
+            </a:pPr>
+            <a:r>
+              <a:t>POSIÇÃO</a:t>
+            </a:r>
+          </a:p>
+        </p:txBody>
+      </p:sp>
+      <p:sp>
+        <p:nvSpPr>
+          <p:cNvPr id="15" name="TextBox 14"/>
+          <p:cNvSpPr txBox="1"/>
+          <p:nvPr/>
+        </p:nvSpPr>
+        <p:spPr>
+          <a:xfrm>
+            <a:off x="6345936" y="1700784"/>
+            <a:ext cx="2286000" cy="384048"/>
+          </a:xfrm>
+          <a:prstGeom prst="rect">
+            <a:avLst/>
+          </a:prstGeom>
+          <a:noFill/>
+        </p:spPr>
+        <p:txBody>
+          <a:bodyPr wrap="square" anchor="t" lIns="0" rIns="0" tIns="0" bIns="0">
+            <a:spAutoFit/>
+          </a:bodyPr>
+          <a:lstStyle/>
+          <a:p>
+            <a:pPr algn="l">
+              <a:defRPr sz="2000" b="1">
                 <a:solidFill>
                   <a:srgbClr val="151515"/>
                 </a:solidFill>
@@ -8627,21 +8736,21 @@
               </a:defRPr>
             </a:pPr>
             <a:r>
-              <a:t>O mês de referência é o do anúncio de encerramento</a:t>
-            </a:r>
-          </a:p>
-        </p:txBody>
-      </p:sp>
-      <p:sp>
-        <p:nvSpPr>
-          <p:cNvPr id="13" name="TextBox 12"/>
-          <p:cNvSpPr txBox="1"/>
-          <p:nvPr/>
-        </p:nvSpPr>
-        <p:spPr>
-          <a:xfrm>
-            <a:off x="822960" y="3364991"/>
-            <a:ext cx="5029200" cy="868680"/>
+              <a:t>1º</a:t>
+            </a:r>
+          </a:p>
+        </p:txBody>
+      </p:sp>
+      <p:sp>
+        <p:nvSpPr>
+          <p:cNvPr id="16" name="TextBox 15"/>
+          <p:cNvSpPr txBox="1"/>
+          <p:nvPr/>
+        </p:nvSpPr>
+        <p:spPr>
+          <a:xfrm>
+            <a:off x="6345936" y="2103120"/>
+            <a:ext cx="2286000" cy="201168"/>
           </a:xfrm>
           <a:prstGeom prst="rect">
             <a:avLst/>
@@ -8655,35 +8764,35 @@
           <a:lstStyle/>
           <a:p>
             <a:pPr algn="l">
-              <a:defRPr sz="1100" b="0">
-                <a:solidFill>
-                  <a:srgbClr val="5D6369"/>
-                </a:solidFill>
-                <a:latin typeface="Arial"/>
-              </a:defRPr>
-            </a:pPr>
-            <a:r>
-              <a:t>Não é a data de registro nem a de emissão. Operações fora do prazo de envio escorregam para o ranking do trimestre seguinte.</a:t>
-            </a:r>
-          </a:p>
-        </p:txBody>
-      </p:sp>
-      <p:sp>
-        <p:nvSpPr>
-          <p:cNvPr id="14" name="Rectangle 13"/>
+              <a:defRPr sz="900" b="0">
+                <a:solidFill>
+                  <a:srgbClr val="8D9399"/>
+                </a:solidFill>
+                <a:latin typeface="Arial"/>
+              </a:defRPr>
+            </a:pPr>
+            <a:r>
+              <a:t>entre 11 coordenadores ativos</a:t>
+            </a:r>
+          </a:p>
+        </p:txBody>
+      </p:sp>
+      <p:sp>
+        <p:nvSpPr>
+          <p:cNvPr id="17" name="Rectangle 16"/>
           <p:cNvSpPr/>
           <p:nvPr/>
         </p:nvSpPr>
         <p:spPr>
           <a:xfrm>
-            <a:off x="6236208" y="2944368"/>
-            <a:ext cx="41148" cy="969264"/>
+            <a:off x="8961119" y="1325880"/>
+            <a:ext cx="2615184" cy="1060704"/>
           </a:xfrm>
           <a:prstGeom prst="rect">
             <a:avLst/>
           </a:prstGeom>
           <a:solidFill>
-            <a:srgbClr val="E36C0A"/>
+            <a:srgbClr val="F5F6F7"/>
           </a:solidFill>
           <a:ln>
             <a:noFill/>
@@ -8714,14 +8823,14 @@
       </p:sp>
       <p:sp>
         <p:nvSpPr>
-          <p:cNvPr id="15" name="TextBox 14"/>
-          <p:cNvSpPr txBox="1"/>
-          <p:nvPr/>
-        </p:nvSpPr>
-        <p:spPr>
-          <a:xfrm>
-            <a:off x="6492240" y="2944368"/>
-            <a:ext cx="5029200" cy="457200"/>
+          <p:cNvPr id="18" name="TextBox 17"/>
+          <p:cNvSpPr txBox="1"/>
+          <p:nvPr/>
+        </p:nvSpPr>
+        <p:spPr>
+          <a:xfrm>
+            <a:off x="9143999" y="1463040"/>
+            <a:ext cx="2286000" cy="201168"/>
           </a:xfrm>
           <a:prstGeom prst="rect">
             <a:avLst/>
@@ -8735,7 +8844,43 @@
           <a:lstStyle/>
           <a:p>
             <a:pPr algn="l">
-              <a:defRPr sz="1300" b="1">
+              <a:defRPr sz="900" b="1">
+                <a:solidFill>
+                  <a:srgbClr val="8D9399"/>
+                </a:solidFill>
+                <a:latin typeface="Arial"/>
+              </a:defRPr>
+            </a:pPr>
+            <a:r>
+              <a:t>OPERAÇÕES</a:t>
+            </a:r>
+          </a:p>
+        </p:txBody>
+      </p:sp>
+      <p:sp>
+        <p:nvSpPr>
+          <p:cNvPr id="19" name="TextBox 18"/>
+          <p:cNvSpPr txBox="1"/>
+          <p:nvPr/>
+        </p:nvSpPr>
+        <p:spPr>
+          <a:xfrm>
+            <a:off x="9143999" y="1700784"/>
+            <a:ext cx="2286000" cy="384048"/>
+          </a:xfrm>
+          <a:prstGeom prst="rect">
+            <a:avLst/>
+          </a:prstGeom>
+          <a:noFill/>
+        </p:spPr>
+        <p:txBody>
+          <a:bodyPr wrap="square" anchor="t" lIns="0" rIns="0" tIns="0" bIns="0">
+            <a:spAutoFit/>
+          </a:bodyPr>
+          <a:lstStyle/>
+          <a:p>
+            <a:pPr algn="l">
+              <a:defRPr sz="2000" b="1">
                 <a:solidFill>
                   <a:srgbClr val="151515"/>
                 </a:solidFill>
@@ -8743,21 +8888,21 @@
               </a:defRPr>
             </a:pPr>
             <a:r>
-              <a:t>É um ranking declaratório</a:t>
-            </a:r>
-          </a:p>
-        </p:txBody>
-      </p:sp>
-      <p:sp>
-        <p:nvSpPr>
-          <p:cNvPr id="16" name="TextBox 15"/>
-          <p:cNvSpPr txBox="1"/>
-          <p:nvPr/>
-        </p:nvSpPr>
-        <p:spPr>
-          <a:xfrm>
-            <a:off x="6492240" y="3364991"/>
-            <a:ext cx="5029200" cy="868680"/>
+              <a:t>19 de 43</a:t>
+            </a:r>
+          </a:p>
+        </p:txBody>
+      </p:sp>
+      <p:sp>
+        <p:nvSpPr>
+          <p:cNvPr id="20" name="TextBox 19"/>
+          <p:cNvSpPr txBox="1"/>
+          <p:nvPr/>
+        </p:nvSpPr>
+        <p:spPr>
+          <a:xfrm>
+            <a:off x="9143999" y="2103120"/>
+            <a:ext cx="2286000" cy="201168"/>
           </a:xfrm>
           <a:prstGeom prst="rect">
             <a:avLst/>
@@ -8771,35 +8916,258 @@
           <a:lstStyle/>
           <a:p>
             <a:pPr algn="l">
-              <a:defRPr sz="1100" b="0">
-                <a:solidFill>
-                  <a:srgbClr val="5D6369"/>
-                </a:solidFill>
-                <a:latin typeface="Arial"/>
-              </a:defRPr>
-            </a:pPr>
-            <a:r>
-              <a:t>Operação cujo formulário-padrão não foi enviado não entra. Boa parte do mercado liderado por administradores e DTVMs fica de fora.</a:t>
-            </a:r>
-          </a:p>
-        </p:txBody>
-      </p:sp>
-      <p:sp>
-        <p:nvSpPr>
-          <p:cNvPr id="17" name="Rectangle 16"/>
+              <a:defRPr sz="900" b="0">
+                <a:solidFill>
+                  <a:srgbClr val="8D9399"/>
+                </a:solidFill>
+                <a:latin typeface="Arial"/>
+              </a:defRPr>
+            </a:pPr>
+            <a:r>
+              <a:t>originadas no semestre</a:t>
+            </a:r>
+          </a:p>
+        </p:txBody>
+      </p:sp>
+      <p:sp>
+        <p:nvSpPr>
+          <p:cNvPr id="21" name="TextBox 20"/>
+          <p:cNvSpPr txBox="1"/>
+          <p:nvPr/>
+        </p:nvSpPr>
+        <p:spPr>
+          <a:xfrm>
+            <a:off x="566928" y="2670048"/>
+            <a:ext cx="640080" cy="274320"/>
+          </a:xfrm>
+          <a:prstGeom prst="rect">
+            <a:avLst/>
+          </a:prstGeom>
+          <a:noFill/>
+        </p:spPr>
+        <p:txBody>
+          <a:bodyPr wrap="square" anchor="t" lIns="0" rIns="0" tIns="0" bIns="0">
+            <a:spAutoFit/>
+          </a:bodyPr>
+          <a:lstStyle/>
+          <a:p>
+            <a:pPr algn="l">
+              <a:defRPr sz="1000" b="1">
+                <a:solidFill>
+                  <a:srgbClr val="8D9399"/>
+                </a:solidFill>
+                <a:latin typeface="Arial"/>
+              </a:defRPr>
+            </a:pPr>
+            <a:r>
+              <a:t>#</a:t>
+            </a:r>
+          </a:p>
+        </p:txBody>
+      </p:sp>
+      <p:sp>
+        <p:nvSpPr>
+          <p:cNvPr id="22" name="TextBox 21"/>
+          <p:cNvSpPr txBox="1"/>
+          <p:nvPr/>
+        </p:nvSpPr>
+        <p:spPr>
+          <a:xfrm>
+            <a:off x="1207007" y="2670048"/>
+            <a:ext cx="4572000" cy="274320"/>
+          </a:xfrm>
+          <a:prstGeom prst="rect">
+            <a:avLst/>
+          </a:prstGeom>
+          <a:noFill/>
+        </p:spPr>
+        <p:txBody>
+          <a:bodyPr wrap="square" anchor="t" lIns="0" rIns="0" tIns="0" bIns="0">
+            <a:spAutoFit/>
+          </a:bodyPr>
+          <a:lstStyle/>
+          <a:p>
+            <a:pPr algn="l">
+              <a:defRPr sz="1000" b="1">
+                <a:solidFill>
+                  <a:srgbClr val="8D9399"/>
+                </a:solidFill>
+                <a:latin typeface="Arial"/>
+              </a:defRPr>
+            </a:pPr>
+            <a:r>
+              <a:t>Coordenador</a:t>
+            </a:r>
+          </a:p>
+        </p:txBody>
+      </p:sp>
+      <p:sp>
+        <p:nvSpPr>
+          <p:cNvPr id="23" name="TextBox 22"/>
+          <p:cNvSpPr txBox="1"/>
+          <p:nvPr/>
+        </p:nvSpPr>
+        <p:spPr>
+          <a:xfrm>
+            <a:off x="5779008" y="2670048"/>
+            <a:ext cx="2286000" cy="274320"/>
+          </a:xfrm>
+          <a:prstGeom prst="rect">
+            <a:avLst/>
+          </a:prstGeom>
+          <a:noFill/>
+        </p:spPr>
+        <p:txBody>
+          <a:bodyPr wrap="square" anchor="t" lIns="0" rIns="0" tIns="0" bIns="0">
+            <a:spAutoFit/>
+          </a:bodyPr>
+          <a:lstStyle/>
+          <a:p>
+            <a:pPr algn="r">
+              <a:defRPr sz="1000" b="1">
+                <a:solidFill>
+                  <a:srgbClr val="8D9399"/>
+                </a:solidFill>
+                <a:latin typeface="Arial"/>
+              </a:defRPr>
+            </a:pPr>
+            <a:r>
+              <a:t>Volume (R$ bi)</a:t>
+            </a:r>
+          </a:p>
+        </p:txBody>
+      </p:sp>
+      <p:sp>
+        <p:nvSpPr>
+          <p:cNvPr id="24" name="TextBox 23"/>
+          <p:cNvSpPr txBox="1"/>
+          <p:nvPr/>
+        </p:nvSpPr>
+        <p:spPr>
+          <a:xfrm>
+            <a:off x="8065007" y="2670048"/>
+            <a:ext cx="1737360" cy="274320"/>
+          </a:xfrm>
+          <a:prstGeom prst="rect">
+            <a:avLst/>
+          </a:prstGeom>
+          <a:noFill/>
+        </p:spPr>
+        <p:txBody>
+          <a:bodyPr wrap="square" anchor="t" lIns="0" rIns="0" tIns="0" bIns="0">
+            <a:spAutoFit/>
+          </a:bodyPr>
+          <a:lstStyle/>
+          <a:p>
+            <a:pPr algn="r">
+              <a:defRPr sz="1000" b="1">
+                <a:solidFill>
+                  <a:srgbClr val="8D9399"/>
+                </a:solidFill>
+                <a:latin typeface="Arial"/>
+              </a:defRPr>
+            </a:pPr>
+            <a:r>
+              <a:t>Part.</a:t>
+            </a:r>
+          </a:p>
+        </p:txBody>
+      </p:sp>
+      <p:sp>
+        <p:nvSpPr>
+          <p:cNvPr id="25" name="TextBox 24"/>
+          <p:cNvSpPr txBox="1"/>
+          <p:nvPr/>
+        </p:nvSpPr>
+        <p:spPr>
+          <a:xfrm>
+            <a:off x="9802367" y="2670048"/>
+            <a:ext cx="1783080" cy="274320"/>
+          </a:xfrm>
+          <a:prstGeom prst="rect">
+            <a:avLst/>
+          </a:prstGeom>
+          <a:noFill/>
+        </p:spPr>
+        <p:txBody>
+          <a:bodyPr wrap="square" anchor="t" lIns="0" rIns="0" tIns="0" bIns="0">
+            <a:spAutoFit/>
+          </a:bodyPr>
+          <a:lstStyle/>
+          <a:p>
+            <a:pPr algn="r">
+              <a:defRPr sz="1000" b="1">
+                <a:solidFill>
+                  <a:srgbClr val="8D9399"/>
+                </a:solidFill>
+                <a:latin typeface="Arial"/>
+              </a:defRPr>
+            </a:pPr>
+            <a:r>
+              <a:t>Nº ops</a:t>
+            </a:r>
+          </a:p>
+        </p:txBody>
+      </p:sp>
+      <p:sp>
+        <p:nvSpPr>
+          <p:cNvPr id="26" name="Rectangle 25"/>
           <p:cNvSpPr/>
           <p:nvPr/>
         </p:nvSpPr>
         <p:spPr>
           <a:xfrm>
-            <a:off x="566928" y="4517136"/>
-            <a:ext cx="41148" cy="969264"/>
+            <a:off x="566928" y="2903220"/>
+            <a:ext cx="11018519" cy="10972"/>
           </a:xfrm>
           <a:prstGeom prst="rect">
             <a:avLst/>
           </a:prstGeom>
           <a:solidFill>
-            <a:srgbClr val="E36C0A"/>
+            <a:srgbClr val="D7DADD"/>
+          </a:solidFill>
+          <a:ln>
+            <a:noFill/>
+          </a:ln>
+        </p:spPr>
+        <p:style>
+          <a:lnRef idx="1">
+            <a:schemeClr val="accent1"/>
+          </a:lnRef>
+          <a:fillRef idx="3">
+            <a:schemeClr val="accent1"/>
+          </a:fillRef>
+          <a:effectRef idx="2">
+            <a:schemeClr val="accent1"/>
+          </a:effectRef>
+          <a:fontRef idx="minor">
+            <a:schemeClr val="lt1"/>
+          </a:fontRef>
+        </p:style>
+        <p:txBody>
+          <a:bodyPr rtlCol="0" anchor="ctr"/>
+          <a:lstStyle/>
+          <a:p>
+            <a:pPr algn="ctr"/>
+          </a:p>
+        </p:txBody>
+      </p:sp>
+      <p:sp>
+        <p:nvSpPr>
+          <p:cNvPr id="27" name="Rectangle 26"/>
+          <p:cNvSpPr/>
+          <p:nvPr/>
+        </p:nvSpPr>
+        <p:spPr>
+          <a:xfrm>
+            <a:off x="457200" y="2948940"/>
+            <a:ext cx="11237976" cy="274320"/>
+          </a:xfrm>
+          <a:prstGeom prst="rect">
+            <a:avLst/>
+          </a:prstGeom>
+          <a:solidFill>
+            <a:srgbClr val="F8E9DE"/>
           </a:solidFill>
           <a:ln>
             <a:noFill/>
@@ -8830,14 +9198,14 @@
       </p:sp>
       <p:sp>
         <p:nvSpPr>
-          <p:cNvPr id="18" name="TextBox 17"/>
-          <p:cNvSpPr txBox="1"/>
-          <p:nvPr/>
-        </p:nvSpPr>
-        <p:spPr>
-          <a:xfrm>
-            <a:off x="822960" y="4517136"/>
-            <a:ext cx="5029200" cy="457200"/>
+          <p:cNvPr id="28" name="TextBox 27"/>
+          <p:cNvSpPr txBox="1"/>
+          <p:nvPr/>
+        </p:nvSpPr>
+        <p:spPr>
+          <a:xfrm>
+            <a:off x="566928" y="2994660"/>
+            <a:ext cx="640080" cy="274320"/>
           </a:xfrm>
           <a:prstGeom prst="rect">
             <a:avLst/>
@@ -8851,7 +9219,7 @@
           <a:lstStyle/>
           <a:p>
             <a:pPr algn="l">
-              <a:defRPr sz="1300" b="1">
+              <a:defRPr sz="1100" b="1">
                 <a:solidFill>
                   <a:srgbClr val="151515"/>
                 </a:solidFill>
@@ -8859,21 +9227,21 @@
               </a:defRPr>
             </a:pPr>
             <a:r>
-              <a:t>Operações de empresas ligadas saem do Tipo 1</a:t>
-            </a:r>
-          </a:p>
-        </p:txBody>
-      </p:sp>
-      <p:sp>
-        <p:nvSpPr>
-          <p:cNvPr id="19" name="TextBox 18"/>
-          <p:cNvSpPr txBox="1"/>
-          <p:nvPr/>
-        </p:nvSpPr>
-        <p:spPr>
-          <a:xfrm>
-            <a:off x="822960" y="4937759"/>
-            <a:ext cx="5029200" cy="868680"/>
+              <a:t>1º</a:t>
+            </a:r>
+          </a:p>
+        </p:txBody>
+      </p:sp>
+      <p:sp>
+        <p:nvSpPr>
+          <p:cNvPr id="29" name="TextBox 28"/>
+          <p:cNvSpPr txBox="1"/>
+          <p:nvPr/>
+        </p:nvSpPr>
+        <p:spPr>
+          <a:xfrm>
+            <a:off x="1207007" y="2994660"/>
+            <a:ext cx="4572000" cy="274320"/>
           </a:xfrm>
           <a:prstGeom prst="rect">
             <a:avLst/>
@@ -8887,145 +9255,137 @@
           <a:lstStyle/>
           <a:p>
             <a:pPr algn="l">
-              <a:defRPr sz="1100" b="0">
-                <a:solidFill>
-                  <a:srgbClr val="5D6369"/>
-                </a:solidFill>
-                <a:latin typeface="Arial"/>
-              </a:defRPr>
-            </a:pPr>
-            <a:r>
-              <a:t>Coordenador com participação de 10% ou mais na emissora, cedente ou originadora vai para o Tipo 3, apurado à parte.</a:t>
-            </a:r>
-          </a:p>
-        </p:txBody>
-      </p:sp>
-      <p:sp>
-        <p:nvSpPr>
-          <p:cNvPr id="20" name="Rectangle 19"/>
+              <a:defRPr sz="1100" b="1">
+                <a:solidFill>
+                  <a:srgbClr val="151515"/>
+                </a:solidFill>
+                <a:latin typeface="Arial"/>
+              </a:defRPr>
+            </a:pPr>
+            <a:r>
+              <a:t>Itaú BBA</a:t>
+            </a:r>
+          </a:p>
+        </p:txBody>
+      </p:sp>
+      <p:sp>
+        <p:nvSpPr>
+          <p:cNvPr id="30" name="TextBox 29"/>
+          <p:cNvSpPr txBox="1"/>
+          <p:nvPr/>
+        </p:nvSpPr>
+        <p:spPr>
+          <a:xfrm>
+            <a:off x="5779008" y="2994660"/>
+            <a:ext cx="2286000" cy="274320"/>
+          </a:xfrm>
+          <a:prstGeom prst="rect">
+            <a:avLst/>
+          </a:prstGeom>
+          <a:noFill/>
+        </p:spPr>
+        <p:txBody>
+          <a:bodyPr wrap="square" anchor="t" lIns="0" rIns="0" tIns="0" bIns="0">
+            <a:spAutoFit/>
+          </a:bodyPr>
+          <a:lstStyle/>
+          <a:p>
+            <a:pPr algn="r">
+              <a:defRPr sz="1100" b="1">
+                <a:solidFill>
+                  <a:srgbClr val="151515"/>
+                </a:solidFill>
+                <a:latin typeface="Arial"/>
+              </a:defRPr>
+            </a:pPr>
+            <a:r>
+              <a:t>11,4</a:t>
+            </a:r>
+          </a:p>
+        </p:txBody>
+      </p:sp>
+      <p:sp>
+        <p:nvSpPr>
+          <p:cNvPr id="31" name="TextBox 30"/>
+          <p:cNvSpPr txBox="1"/>
+          <p:nvPr/>
+        </p:nvSpPr>
+        <p:spPr>
+          <a:xfrm>
+            <a:off x="8065007" y="2994660"/>
+            <a:ext cx="1737360" cy="274320"/>
+          </a:xfrm>
+          <a:prstGeom prst="rect">
+            <a:avLst/>
+          </a:prstGeom>
+          <a:noFill/>
+        </p:spPr>
+        <p:txBody>
+          <a:bodyPr wrap="square" anchor="t" lIns="0" rIns="0" tIns="0" bIns="0">
+            <a:spAutoFit/>
+          </a:bodyPr>
+          <a:lstStyle/>
+          <a:p>
+            <a:pPr algn="r">
+              <a:defRPr sz="1100" b="1">
+                <a:solidFill>
+                  <a:srgbClr val="151515"/>
+                </a:solidFill>
+                <a:latin typeface="Arial"/>
+              </a:defRPr>
+            </a:pPr>
+            <a:r>
+              <a:t>45,7%</a:t>
+            </a:r>
+          </a:p>
+        </p:txBody>
+      </p:sp>
+      <p:sp>
+        <p:nvSpPr>
+          <p:cNvPr id="32" name="TextBox 31"/>
+          <p:cNvSpPr txBox="1"/>
+          <p:nvPr/>
+        </p:nvSpPr>
+        <p:spPr>
+          <a:xfrm>
+            <a:off x="9802367" y="2994660"/>
+            <a:ext cx="1783080" cy="274320"/>
+          </a:xfrm>
+          <a:prstGeom prst="rect">
+            <a:avLst/>
+          </a:prstGeom>
+          <a:noFill/>
+        </p:spPr>
+        <p:txBody>
+          <a:bodyPr wrap="square" anchor="t" lIns="0" rIns="0" tIns="0" bIns="0">
+            <a:spAutoFit/>
+          </a:bodyPr>
+          <a:lstStyle/>
+          <a:p>
+            <a:pPr algn="r">
+              <a:defRPr sz="1100" b="1">
+                <a:solidFill>
+                  <a:srgbClr val="151515"/>
+                </a:solidFill>
+                <a:latin typeface="Arial"/>
+              </a:defRPr>
+            </a:pPr>
+            <a:r>
+              <a:t>19</a:t>
+            </a:r>
+          </a:p>
+        </p:txBody>
+      </p:sp>
+      <p:sp>
+        <p:nvSpPr>
+          <p:cNvPr id="33" name="Rectangle 32"/>
           <p:cNvSpPr/>
           <p:nvPr/>
         </p:nvSpPr>
         <p:spPr>
           <a:xfrm>
-            <a:off x="6236208" y="4517136"/>
-            <a:ext cx="41148" cy="969264"/>
-          </a:xfrm>
-          <a:prstGeom prst="rect">
-            <a:avLst/>
-          </a:prstGeom>
-          <a:solidFill>
-            <a:srgbClr val="E36C0A"/>
-          </a:solidFill>
-          <a:ln>
-            <a:noFill/>
-          </a:ln>
-          <a:effectLst/>
-        </p:spPr>
-        <p:style>
-          <a:lnRef idx="1">
-            <a:schemeClr val="accent1"/>
-          </a:lnRef>
-          <a:fillRef idx="3">
-            <a:schemeClr val="accent1"/>
-          </a:fillRef>
-          <a:effectRef idx="2">
-            <a:schemeClr val="accent1"/>
-          </a:effectRef>
-          <a:fontRef idx="minor">
-            <a:schemeClr val="lt1"/>
-          </a:fontRef>
-        </p:style>
-        <p:txBody>
-          <a:bodyPr rtlCol="0" anchor="ctr"/>
-          <a:lstStyle/>
-          <a:p>
-            <a:pPr algn="ctr"/>
-          </a:p>
-        </p:txBody>
-      </p:sp>
-      <p:sp>
-        <p:nvSpPr>
-          <p:cNvPr id="21" name="TextBox 20"/>
-          <p:cNvSpPr txBox="1"/>
-          <p:nvPr/>
-        </p:nvSpPr>
-        <p:spPr>
-          <a:xfrm>
-            <a:off x="6492240" y="4517136"/>
-            <a:ext cx="5029200" cy="457200"/>
-          </a:xfrm>
-          <a:prstGeom prst="rect">
-            <a:avLst/>
-          </a:prstGeom>
-          <a:noFill/>
-        </p:spPr>
-        <p:txBody>
-          <a:bodyPr wrap="square" anchor="t" lIns="0" rIns="0" tIns="0" bIns="0">
-            <a:spAutoFit/>
-          </a:bodyPr>
-          <a:lstStyle/>
-          <a:p>
-            <a:pPr algn="l">
-              <a:defRPr sz="1300" b="1">
-                <a:solidFill>
-                  <a:srgbClr val="151515"/>
-                </a:solidFill>
-                <a:latin typeface="Arial"/>
-              </a:defRPr>
-            </a:pPr>
-            <a:r>
-              <a:t>Perímetro do Tipo 1</a:t>
-            </a:r>
-          </a:p>
-        </p:txBody>
-      </p:sp>
-      <p:sp>
-        <p:nvSpPr>
-          <p:cNvPr id="22" name="TextBox 21"/>
-          <p:cNvSpPr txBox="1"/>
-          <p:nvPr/>
-        </p:nvSpPr>
-        <p:spPr>
-          <a:xfrm>
-            <a:off x="6492240" y="4937759"/>
-            <a:ext cx="5029200" cy="868680"/>
-          </a:xfrm>
-          <a:prstGeom prst="rect">
-            <a:avLst/>
-          </a:prstGeom>
-          <a:noFill/>
-        </p:spPr>
-        <p:txBody>
-          <a:bodyPr wrap="square" anchor="t" lIns="0" rIns="0" tIns="0" bIns="0">
-            <a:spAutoFit/>
-          </a:bodyPr>
-          <a:lstStyle/>
-          <a:p>
-            <a:pPr algn="l">
-              <a:defRPr sz="1100" b="0">
-                <a:solidFill>
-                  <a:srgbClr val="5D6369"/>
-                </a:solidFill>
-                <a:latin typeface="Arial"/>
-              </a:defRPr>
-            </a:pPr>
-            <a:r>
-              <a:t>Debêntures simples, notas promissórias, notas comerciais, CPR-F e securitização (FIDC, CRI, CRA, CR). FII, FIAGRO e FIP-IE ficam nas operações híbridas e não entram.</a:t>
-            </a:r>
-          </a:p>
-        </p:txBody>
-      </p:sp>
-      <p:sp>
-        <p:nvSpPr>
-          <p:cNvPr id="23" name="Rectangle 22"/>
-          <p:cNvSpPr/>
-          <p:nvPr/>
-        </p:nvSpPr>
-        <p:spPr>
-          <a:xfrm>
-            <a:off x="566928" y="6355080"/>
-            <a:ext cx="11018520" cy="9144"/>
+            <a:off x="566928" y="3223260"/>
+            <a:ext cx="11018519" cy="7315"/>
           </a:xfrm>
           <a:prstGeom prst="rect">
             <a:avLst/>
@@ -9061,7 +9421,1827 @@
       </p:sp>
       <p:sp>
         <p:nvSpPr>
-          <p:cNvPr id="24" name="TextBox 23"/>
+          <p:cNvPr id="34" name="TextBox 33"/>
+          <p:cNvSpPr txBox="1"/>
+          <p:nvPr/>
+        </p:nvSpPr>
+        <p:spPr>
+          <a:xfrm>
+            <a:off x="566928" y="3268979"/>
+            <a:ext cx="640080" cy="274320"/>
+          </a:xfrm>
+          <a:prstGeom prst="rect">
+            <a:avLst/>
+          </a:prstGeom>
+          <a:noFill/>
+        </p:spPr>
+        <p:txBody>
+          <a:bodyPr wrap="square" anchor="t" lIns="0" rIns="0" tIns="0" bIns="0">
+            <a:spAutoFit/>
+          </a:bodyPr>
+          <a:lstStyle/>
+          <a:p>
+            <a:pPr algn="l">
+              <a:defRPr sz="1100" b="0">
+                <a:solidFill>
+                  <a:srgbClr val="30353A"/>
+                </a:solidFill>
+                <a:latin typeface="Arial"/>
+              </a:defRPr>
+            </a:pPr>
+            <a:r>
+              <a:t>2º</a:t>
+            </a:r>
+          </a:p>
+        </p:txBody>
+      </p:sp>
+      <p:sp>
+        <p:nvSpPr>
+          <p:cNvPr id="35" name="TextBox 34"/>
+          <p:cNvSpPr txBox="1"/>
+          <p:nvPr/>
+        </p:nvSpPr>
+        <p:spPr>
+          <a:xfrm>
+            <a:off x="1207007" y="3268979"/>
+            <a:ext cx="4572000" cy="274320"/>
+          </a:xfrm>
+          <a:prstGeom prst="rect">
+            <a:avLst/>
+          </a:prstGeom>
+          <a:noFill/>
+        </p:spPr>
+        <p:txBody>
+          <a:bodyPr wrap="square" anchor="t" lIns="0" rIns="0" tIns="0" bIns="0">
+            <a:spAutoFit/>
+          </a:bodyPr>
+          <a:lstStyle/>
+          <a:p>
+            <a:pPr algn="l">
+              <a:defRPr sz="1100" b="0">
+                <a:solidFill>
+                  <a:srgbClr val="30353A"/>
+                </a:solidFill>
+                <a:latin typeface="Arial"/>
+              </a:defRPr>
+            </a:pPr>
+            <a:r>
+              <a:t>Bradesco BBI</a:t>
+            </a:r>
+          </a:p>
+        </p:txBody>
+      </p:sp>
+      <p:sp>
+        <p:nvSpPr>
+          <p:cNvPr id="36" name="TextBox 35"/>
+          <p:cNvSpPr txBox="1"/>
+          <p:nvPr/>
+        </p:nvSpPr>
+        <p:spPr>
+          <a:xfrm>
+            <a:off x="5779008" y="3268979"/>
+            <a:ext cx="2286000" cy="274320"/>
+          </a:xfrm>
+          <a:prstGeom prst="rect">
+            <a:avLst/>
+          </a:prstGeom>
+          <a:noFill/>
+        </p:spPr>
+        <p:txBody>
+          <a:bodyPr wrap="square" anchor="t" lIns="0" rIns="0" tIns="0" bIns="0">
+            <a:spAutoFit/>
+          </a:bodyPr>
+          <a:lstStyle/>
+          <a:p>
+            <a:pPr algn="r">
+              <a:defRPr sz="1100" b="0">
+                <a:solidFill>
+                  <a:srgbClr val="30353A"/>
+                </a:solidFill>
+                <a:latin typeface="Arial"/>
+              </a:defRPr>
+            </a:pPr>
+            <a:r>
+              <a:t>5,2</a:t>
+            </a:r>
+          </a:p>
+        </p:txBody>
+      </p:sp>
+      <p:sp>
+        <p:nvSpPr>
+          <p:cNvPr id="37" name="TextBox 36"/>
+          <p:cNvSpPr txBox="1"/>
+          <p:nvPr/>
+        </p:nvSpPr>
+        <p:spPr>
+          <a:xfrm>
+            <a:off x="8065007" y="3268979"/>
+            <a:ext cx="1737360" cy="274320"/>
+          </a:xfrm>
+          <a:prstGeom prst="rect">
+            <a:avLst/>
+          </a:prstGeom>
+          <a:noFill/>
+        </p:spPr>
+        <p:txBody>
+          <a:bodyPr wrap="square" anchor="t" lIns="0" rIns="0" tIns="0" bIns="0">
+            <a:spAutoFit/>
+          </a:bodyPr>
+          <a:lstStyle/>
+          <a:p>
+            <a:pPr algn="r">
+              <a:defRPr sz="1100" b="0">
+                <a:solidFill>
+                  <a:srgbClr val="30353A"/>
+                </a:solidFill>
+                <a:latin typeface="Arial"/>
+              </a:defRPr>
+            </a:pPr>
+            <a:r>
+              <a:t>20,6%</a:t>
+            </a:r>
+          </a:p>
+        </p:txBody>
+      </p:sp>
+      <p:sp>
+        <p:nvSpPr>
+          <p:cNvPr id="38" name="TextBox 37"/>
+          <p:cNvSpPr txBox="1"/>
+          <p:nvPr/>
+        </p:nvSpPr>
+        <p:spPr>
+          <a:xfrm>
+            <a:off x="9802367" y="3268979"/>
+            <a:ext cx="1783080" cy="274320"/>
+          </a:xfrm>
+          <a:prstGeom prst="rect">
+            <a:avLst/>
+          </a:prstGeom>
+          <a:noFill/>
+        </p:spPr>
+        <p:txBody>
+          <a:bodyPr wrap="square" anchor="t" lIns="0" rIns="0" tIns="0" bIns="0">
+            <a:spAutoFit/>
+          </a:bodyPr>
+          <a:lstStyle/>
+          <a:p>
+            <a:pPr algn="r">
+              <a:defRPr sz="1100" b="0">
+                <a:solidFill>
+                  <a:srgbClr val="30353A"/>
+                </a:solidFill>
+                <a:latin typeface="Arial"/>
+              </a:defRPr>
+            </a:pPr>
+            <a:r>
+              <a:t>9</a:t>
+            </a:r>
+          </a:p>
+        </p:txBody>
+      </p:sp>
+      <p:sp>
+        <p:nvSpPr>
+          <p:cNvPr id="39" name="Rectangle 38"/>
+          <p:cNvSpPr/>
+          <p:nvPr/>
+        </p:nvSpPr>
+        <p:spPr>
+          <a:xfrm>
+            <a:off x="566928" y="3497579"/>
+            <a:ext cx="11018519" cy="7315"/>
+          </a:xfrm>
+          <a:prstGeom prst="rect">
+            <a:avLst/>
+          </a:prstGeom>
+          <a:solidFill>
+            <a:srgbClr val="E7E9EB"/>
+          </a:solidFill>
+          <a:ln>
+            <a:noFill/>
+          </a:ln>
+        </p:spPr>
+        <p:style>
+          <a:lnRef idx="1">
+            <a:schemeClr val="accent1"/>
+          </a:lnRef>
+          <a:fillRef idx="3">
+            <a:schemeClr val="accent1"/>
+          </a:fillRef>
+          <a:effectRef idx="2">
+            <a:schemeClr val="accent1"/>
+          </a:effectRef>
+          <a:fontRef idx="minor">
+            <a:schemeClr val="lt1"/>
+          </a:fontRef>
+        </p:style>
+        <p:txBody>
+          <a:bodyPr rtlCol="0" anchor="ctr"/>
+          <a:lstStyle/>
+          <a:p>
+            <a:pPr algn="ctr"/>
+          </a:p>
+        </p:txBody>
+      </p:sp>
+      <p:sp>
+        <p:nvSpPr>
+          <p:cNvPr id="40" name="TextBox 39"/>
+          <p:cNvSpPr txBox="1"/>
+          <p:nvPr/>
+        </p:nvSpPr>
+        <p:spPr>
+          <a:xfrm>
+            <a:off x="566928" y="3543299"/>
+            <a:ext cx="640080" cy="274320"/>
+          </a:xfrm>
+          <a:prstGeom prst="rect">
+            <a:avLst/>
+          </a:prstGeom>
+          <a:noFill/>
+        </p:spPr>
+        <p:txBody>
+          <a:bodyPr wrap="square" anchor="t" lIns="0" rIns="0" tIns="0" bIns="0">
+            <a:spAutoFit/>
+          </a:bodyPr>
+          <a:lstStyle/>
+          <a:p>
+            <a:pPr algn="l">
+              <a:defRPr sz="1100" b="0">
+                <a:solidFill>
+                  <a:srgbClr val="30353A"/>
+                </a:solidFill>
+                <a:latin typeface="Arial"/>
+              </a:defRPr>
+            </a:pPr>
+            <a:r>
+              <a:t>3º</a:t>
+            </a:r>
+          </a:p>
+        </p:txBody>
+      </p:sp>
+      <p:sp>
+        <p:nvSpPr>
+          <p:cNvPr id="41" name="TextBox 40"/>
+          <p:cNvSpPr txBox="1"/>
+          <p:nvPr/>
+        </p:nvSpPr>
+        <p:spPr>
+          <a:xfrm>
+            <a:off x="1207007" y="3543299"/>
+            <a:ext cx="4572000" cy="274320"/>
+          </a:xfrm>
+          <a:prstGeom prst="rect">
+            <a:avLst/>
+          </a:prstGeom>
+          <a:noFill/>
+        </p:spPr>
+        <p:txBody>
+          <a:bodyPr wrap="square" anchor="t" lIns="0" rIns="0" tIns="0" bIns="0">
+            <a:spAutoFit/>
+          </a:bodyPr>
+          <a:lstStyle/>
+          <a:p>
+            <a:pPr algn="l">
+              <a:defRPr sz="1100" b="0">
+                <a:solidFill>
+                  <a:srgbClr val="30353A"/>
+                </a:solidFill>
+                <a:latin typeface="Arial"/>
+              </a:defRPr>
+            </a:pPr>
+            <a:r>
+              <a:t>UBS BB</a:t>
+            </a:r>
+          </a:p>
+        </p:txBody>
+      </p:sp>
+      <p:sp>
+        <p:nvSpPr>
+          <p:cNvPr id="42" name="TextBox 41"/>
+          <p:cNvSpPr txBox="1"/>
+          <p:nvPr/>
+        </p:nvSpPr>
+        <p:spPr>
+          <a:xfrm>
+            <a:off x="5779008" y="3543299"/>
+            <a:ext cx="2286000" cy="274320"/>
+          </a:xfrm>
+          <a:prstGeom prst="rect">
+            <a:avLst/>
+          </a:prstGeom>
+          <a:noFill/>
+        </p:spPr>
+        <p:txBody>
+          <a:bodyPr wrap="square" anchor="t" lIns="0" rIns="0" tIns="0" bIns="0">
+            <a:spAutoFit/>
+          </a:bodyPr>
+          <a:lstStyle/>
+          <a:p>
+            <a:pPr algn="r">
+              <a:defRPr sz="1100" b="0">
+                <a:solidFill>
+                  <a:srgbClr val="30353A"/>
+                </a:solidFill>
+                <a:latin typeface="Arial"/>
+              </a:defRPr>
+            </a:pPr>
+            <a:r>
+              <a:t>3,3</a:t>
+            </a:r>
+          </a:p>
+        </p:txBody>
+      </p:sp>
+      <p:sp>
+        <p:nvSpPr>
+          <p:cNvPr id="43" name="TextBox 42"/>
+          <p:cNvSpPr txBox="1"/>
+          <p:nvPr/>
+        </p:nvSpPr>
+        <p:spPr>
+          <a:xfrm>
+            <a:off x="8065007" y="3543299"/>
+            <a:ext cx="1737360" cy="274320"/>
+          </a:xfrm>
+          <a:prstGeom prst="rect">
+            <a:avLst/>
+          </a:prstGeom>
+          <a:noFill/>
+        </p:spPr>
+        <p:txBody>
+          <a:bodyPr wrap="square" anchor="t" lIns="0" rIns="0" tIns="0" bIns="0">
+            <a:spAutoFit/>
+          </a:bodyPr>
+          <a:lstStyle/>
+          <a:p>
+            <a:pPr algn="r">
+              <a:defRPr sz="1100" b="0">
+                <a:solidFill>
+                  <a:srgbClr val="30353A"/>
+                </a:solidFill>
+                <a:latin typeface="Arial"/>
+              </a:defRPr>
+            </a:pPr>
+            <a:r>
+              <a:t>13,2%</a:t>
+            </a:r>
+          </a:p>
+        </p:txBody>
+      </p:sp>
+      <p:sp>
+        <p:nvSpPr>
+          <p:cNvPr id="44" name="TextBox 43"/>
+          <p:cNvSpPr txBox="1"/>
+          <p:nvPr/>
+        </p:nvSpPr>
+        <p:spPr>
+          <a:xfrm>
+            <a:off x="9802367" y="3543299"/>
+            <a:ext cx="1783080" cy="274320"/>
+          </a:xfrm>
+          <a:prstGeom prst="rect">
+            <a:avLst/>
+          </a:prstGeom>
+          <a:noFill/>
+        </p:spPr>
+        <p:txBody>
+          <a:bodyPr wrap="square" anchor="t" lIns="0" rIns="0" tIns="0" bIns="0">
+            <a:spAutoFit/>
+          </a:bodyPr>
+          <a:lstStyle/>
+          <a:p>
+            <a:pPr algn="r">
+              <a:defRPr sz="1100" b="0">
+                <a:solidFill>
+                  <a:srgbClr val="30353A"/>
+                </a:solidFill>
+                <a:latin typeface="Arial"/>
+              </a:defRPr>
+            </a:pPr>
+            <a:r>
+              <a:t>5</a:t>
+            </a:r>
+          </a:p>
+        </p:txBody>
+      </p:sp>
+      <p:sp>
+        <p:nvSpPr>
+          <p:cNvPr id="45" name="Rectangle 44"/>
+          <p:cNvSpPr/>
+          <p:nvPr/>
+        </p:nvSpPr>
+        <p:spPr>
+          <a:xfrm>
+            <a:off x="566928" y="3771900"/>
+            <a:ext cx="11018519" cy="7315"/>
+          </a:xfrm>
+          <a:prstGeom prst="rect">
+            <a:avLst/>
+          </a:prstGeom>
+          <a:solidFill>
+            <a:srgbClr val="E7E9EB"/>
+          </a:solidFill>
+          <a:ln>
+            <a:noFill/>
+          </a:ln>
+        </p:spPr>
+        <p:style>
+          <a:lnRef idx="1">
+            <a:schemeClr val="accent1"/>
+          </a:lnRef>
+          <a:fillRef idx="3">
+            <a:schemeClr val="accent1"/>
+          </a:fillRef>
+          <a:effectRef idx="2">
+            <a:schemeClr val="accent1"/>
+          </a:effectRef>
+          <a:fontRef idx="minor">
+            <a:schemeClr val="lt1"/>
+          </a:fontRef>
+        </p:style>
+        <p:txBody>
+          <a:bodyPr rtlCol="0" anchor="ctr"/>
+          <a:lstStyle/>
+          <a:p>
+            <a:pPr algn="ctr"/>
+          </a:p>
+        </p:txBody>
+      </p:sp>
+      <p:sp>
+        <p:nvSpPr>
+          <p:cNvPr id="46" name="TextBox 45"/>
+          <p:cNvSpPr txBox="1"/>
+          <p:nvPr/>
+        </p:nvSpPr>
+        <p:spPr>
+          <a:xfrm>
+            <a:off x="566928" y="3817620"/>
+            <a:ext cx="640080" cy="274320"/>
+          </a:xfrm>
+          <a:prstGeom prst="rect">
+            <a:avLst/>
+          </a:prstGeom>
+          <a:noFill/>
+        </p:spPr>
+        <p:txBody>
+          <a:bodyPr wrap="square" anchor="t" lIns="0" rIns="0" tIns="0" bIns="0">
+            <a:spAutoFit/>
+          </a:bodyPr>
+          <a:lstStyle/>
+          <a:p>
+            <a:pPr algn="l">
+              <a:defRPr sz="1100" b="0">
+                <a:solidFill>
+                  <a:srgbClr val="30353A"/>
+                </a:solidFill>
+                <a:latin typeface="Arial"/>
+              </a:defRPr>
+            </a:pPr>
+            <a:r>
+              <a:t>4º</a:t>
+            </a:r>
+          </a:p>
+        </p:txBody>
+      </p:sp>
+      <p:sp>
+        <p:nvSpPr>
+          <p:cNvPr id="47" name="TextBox 46"/>
+          <p:cNvSpPr txBox="1"/>
+          <p:nvPr/>
+        </p:nvSpPr>
+        <p:spPr>
+          <a:xfrm>
+            <a:off x="1207007" y="3817620"/>
+            <a:ext cx="4572000" cy="274320"/>
+          </a:xfrm>
+          <a:prstGeom prst="rect">
+            <a:avLst/>
+          </a:prstGeom>
+          <a:noFill/>
+        </p:spPr>
+        <p:txBody>
+          <a:bodyPr wrap="square" anchor="t" lIns="0" rIns="0" tIns="0" bIns="0">
+            <a:spAutoFit/>
+          </a:bodyPr>
+          <a:lstStyle/>
+          <a:p>
+            <a:pPr algn="l">
+              <a:defRPr sz="1100" b="0">
+                <a:solidFill>
+                  <a:srgbClr val="30353A"/>
+                </a:solidFill>
+                <a:latin typeface="Arial"/>
+              </a:defRPr>
+            </a:pPr>
+            <a:r>
+              <a:t>ABC Brasil</a:t>
+            </a:r>
+          </a:p>
+        </p:txBody>
+      </p:sp>
+      <p:sp>
+        <p:nvSpPr>
+          <p:cNvPr id="48" name="TextBox 47"/>
+          <p:cNvSpPr txBox="1"/>
+          <p:nvPr/>
+        </p:nvSpPr>
+        <p:spPr>
+          <a:xfrm>
+            <a:off x="5779008" y="3817620"/>
+            <a:ext cx="2286000" cy="274320"/>
+          </a:xfrm>
+          <a:prstGeom prst="rect">
+            <a:avLst/>
+          </a:prstGeom>
+          <a:noFill/>
+        </p:spPr>
+        <p:txBody>
+          <a:bodyPr wrap="square" anchor="t" lIns="0" rIns="0" tIns="0" bIns="0">
+            <a:spAutoFit/>
+          </a:bodyPr>
+          <a:lstStyle/>
+          <a:p>
+            <a:pPr algn="r">
+              <a:defRPr sz="1100" b="0">
+                <a:solidFill>
+                  <a:srgbClr val="30353A"/>
+                </a:solidFill>
+                <a:latin typeface="Arial"/>
+              </a:defRPr>
+            </a:pPr>
+            <a:r>
+              <a:t>1,1</a:t>
+            </a:r>
+          </a:p>
+        </p:txBody>
+      </p:sp>
+      <p:sp>
+        <p:nvSpPr>
+          <p:cNvPr id="49" name="TextBox 48"/>
+          <p:cNvSpPr txBox="1"/>
+          <p:nvPr/>
+        </p:nvSpPr>
+        <p:spPr>
+          <a:xfrm>
+            <a:off x="8065007" y="3817620"/>
+            <a:ext cx="1737360" cy="274320"/>
+          </a:xfrm>
+          <a:prstGeom prst="rect">
+            <a:avLst/>
+          </a:prstGeom>
+          <a:noFill/>
+        </p:spPr>
+        <p:txBody>
+          <a:bodyPr wrap="square" anchor="t" lIns="0" rIns="0" tIns="0" bIns="0">
+            <a:spAutoFit/>
+          </a:bodyPr>
+          <a:lstStyle/>
+          <a:p>
+            <a:pPr algn="r">
+              <a:defRPr sz="1100" b="0">
+                <a:solidFill>
+                  <a:srgbClr val="30353A"/>
+                </a:solidFill>
+                <a:latin typeface="Arial"/>
+              </a:defRPr>
+            </a:pPr>
+            <a:r>
+              <a:t>4,4%</a:t>
+            </a:r>
+          </a:p>
+        </p:txBody>
+      </p:sp>
+      <p:sp>
+        <p:nvSpPr>
+          <p:cNvPr id="50" name="TextBox 49"/>
+          <p:cNvSpPr txBox="1"/>
+          <p:nvPr/>
+        </p:nvSpPr>
+        <p:spPr>
+          <a:xfrm>
+            <a:off x="9802367" y="3817620"/>
+            <a:ext cx="1783080" cy="274320"/>
+          </a:xfrm>
+          <a:prstGeom prst="rect">
+            <a:avLst/>
+          </a:prstGeom>
+          <a:noFill/>
+        </p:spPr>
+        <p:txBody>
+          <a:bodyPr wrap="square" anchor="t" lIns="0" rIns="0" tIns="0" bIns="0">
+            <a:spAutoFit/>
+          </a:bodyPr>
+          <a:lstStyle/>
+          <a:p>
+            <a:pPr algn="r">
+              <a:defRPr sz="1100" b="0">
+                <a:solidFill>
+                  <a:srgbClr val="30353A"/>
+                </a:solidFill>
+                <a:latin typeface="Arial"/>
+              </a:defRPr>
+            </a:pPr>
+            <a:r>
+              <a:t>3</a:t>
+            </a:r>
+          </a:p>
+        </p:txBody>
+      </p:sp>
+      <p:sp>
+        <p:nvSpPr>
+          <p:cNvPr id="51" name="Rectangle 50"/>
+          <p:cNvSpPr/>
+          <p:nvPr/>
+        </p:nvSpPr>
+        <p:spPr>
+          <a:xfrm>
+            <a:off x="566928" y="4046220"/>
+            <a:ext cx="11018519" cy="7315"/>
+          </a:xfrm>
+          <a:prstGeom prst="rect">
+            <a:avLst/>
+          </a:prstGeom>
+          <a:solidFill>
+            <a:srgbClr val="E7E9EB"/>
+          </a:solidFill>
+          <a:ln>
+            <a:noFill/>
+          </a:ln>
+        </p:spPr>
+        <p:style>
+          <a:lnRef idx="1">
+            <a:schemeClr val="accent1"/>
+          </a:lnRef>
+          <a:fillRef idx="3">
+            <a:schemeClr val="accent1"/>
+          </a:fillRef>
+          <a:effectRef idx="2">
+            <a:schemeClr val="accent1"/>
+          </a:effectRef>
+          <a:fontRef idx="minor">
+            <a:schemeClr val="lt1"/>
+          </a:fontRef>
+        </p:style>
+        <p:txBody>
+          <a:bodyPr rtlCol="0" anchor="ctr"/>
+          <a:lstStyle/>
+          <a:p>
+            <a:pPr algn="ctr"/>
+          </a:p>
+        </p:txBody>
+      </p:sp>
+      <p:sp>
+        <p:nvSpPr>
+          <p:cNvPr id="52" name="TextBox 51"/>
+          <p:cNvSpPr txBox="1"/>
+          <p:nvPr/>
+        </p:nvSpPr>
+        <p:spPr>
+          <a:xfrm>
+            <a:off x="566928" y="4091939"/>
+            <a:ext cx="640080" cy="274320"/>
+          </a:xfrm>
+          <a:prstGeom prst="rect">
+            <a:avLst/>
+          </a:prstGeom>
+          <a:noFill/>
+        </p:spPr>
+        <p:txBody>
+          <a:bodyPr wrap="square" anchor="t" lIns="0" rIns="0" tIns="0" bIns="0">
+            <a:spAutoFit/>
+          </a:bodyPr>
+          <a:lstStyle/>
+          <a:p>
+            <a:pPr algn="l">
+              <a:defRPr sz="1100" b="0">
+                <a:solidFill>
+                  <a:srgbClr val="30353A"/>
+                </a:solidFill>
+                <a:latin typeface="Arial"/>
+              </a:defRPr>
+            </a:pPr>
+            <a:r>
+              <a:t>5º</a:t>
+            </a:r>
+          </a:p>
+        </p:txBody>
+      </p:sp>
+      <p:sp>
+        <p:nvSpPr>
+          <p:cNvPr id="53" name="TextBox 52"/>
+          <p:cNvSpPr txBox="1"/>
+          <p:nvPr/>
+        </p:nvSpPr>
+        <p:spPr>
+          <a:xfrm>
+            <a:off x="1207007" y="4091939"/>
+            <a:ext cx="4572000" cy="274320"/>
+          </a:xfrm>
+          <a:prstGeom prst="rect">
+            <a:avLst/>
+          </a:prstGeom>
+          <a:noFill/>
+        </p:spPr>
+        <p:txBody>
+          <a:bodyPr wrap="square" anchor="t" lIns="0" rIns="0" tIns="0" bIns="0">
+            <a:spAutoFit/>
+          </a:bodyPr>
+          <a:lstStyle/>
+          <a:p>
+            <a:pPr algn="l">
+              <a:defRPr sz="1100" b="0">
+                <a:solidFill>
+                  <a:srgbClr val="30353A"/>
+                </a:solidFill>
+                <a:latin typeface="Arial"/>
+              </a:defRPr>
+            </a:pPr>
+            <a:r>
+              <a:t>BTG Pactual</a:t>
+            </a:r>
+          </a:p>
+        </p:txBody>
+      </p:sp>
+      <p:sp>
+        <p:nvSpPr>
+          <p:cNvPr id="54" name="TextBox 53"/>
+          <p:cNvSpPr txBox="1"/>
+          <p:nvPr/>
+        </p:nvSpPr>
+        <p:spPr>
+          <a:xfrm>
+            <a:off x="5779008" y="4091939"/>
+            <a:ext cx="2286000" cy="274320"/>
+          </a:xfrm>
+          <a:prstGeom prst="rect">
+            <a:avLst/>
+          </a:prstGeom>
+          <a:noFill/>
+        </p:spPr>
+        <p:txBody>
+          <a:bodyPr wrap="square" anchor="t" lIns="0" rIns="0" tIns="0" bIns="0">
+            <a:spAutoFit/>
+          </a:bodyPr>
+          <a:lstStyle/>
+          <a:p>
+            <a:pPr algn="r">
+              <a:defRPr sz="1100" b="0">
+                <a:solidFill>
+                  <a:srgbClr val="30353A"/>
+                </a:solidFill>
+                <a:latin typeface="Arial"/>
+              </a:defRPr>
+            </a:pPr>
+            <a:r>
+              <a:t>1,0</a:t>
+            </a:r>
+          </a:p>
+        </p:txBody>
+      </p:sp>
+      <p:sp>
+        <p:nvSpPr>
+          <p:cNvPr id="55" name="TextBox 54"/>
+          <p:cNvSpPr txBox="1"/>
+          <p:nvPr/>
+        </p:nvSpPr>
+        <p:spPr>
+          <a:xfrm>
+            <a:off x="8065007" y="4091939"/>
+            <a:ext cx="1737360" cy="274320"/>
+          </a:xfrm>
+          <a:prstGeom prst="rect">
+            <a:avLst/>
+          </a:prstGeom>
+          <a:noFill/>
+        </p:spPr>
+        <p:txBody>
+          <a:bodyPr wrap="square" anchor="t" lIns="0" rIns="0" tIns="0" bIns="0">
+            <a:spAutoFit/>
+          </a:bodyPr>
+          <a:lstStyle/>
+          <a:p>
+            <a:pPr algn="r">
+              <a:defRPr sz="1100" b="0">
+                <a:solidFill>
+                  <a:srgbClr val="30353A"/>
+                </a:solidFill>
+                <a:latin typeface="Arial"/>
+              </a:defRPr>
+            </a:pPr>
+            <a:r>
+              <a:t>4,1%</a:t>
+            </a:r>
+          </a:p>
+        </p:txBody>
+      </p:sp>
+      <p:sp>
+        <p:nvSpPr>
+          <p:cNvPr id="56" name="TextBox 55"/>
+          <p:cNvSpPr txBox="1"/>
+          <p:nvPr/>
+        </p:nvSpPr>
+        <p:spPr>
+          <a:xfrm>
+            <a:off x="9802367" y="4091939"/>
+            <a:ext cx="1783080" cy="274320"/>
+          </a:xfrm>
+          <a:prstGeom prst="rect">
+            <a:avLst/>
+          </a:prstGeom>
+          <a:noFill/>
+        </p:spPr>
+        <p:txBody>
+          <a:bodyPr wrap="square" anchor="t" lIns="0" rIns="0" tIns="0" bIns="0">
+            <a:spAutoFit/>
+          </a:bodyPr>
+          <a:lstStyle/>
+          <a:p>
+            <a:pPr algn="r">
+              <a:defRPr sz="1100" b="0">
+                <a:solidFill>
+                  <a:srgbClr val="30353A"/>
+                </a:solidFill>
+                <a:latin typeface="Arial"/>
+              </a:defRPr>
+            </a:pPr>
+            <a:r>
+              <a:t>1</a:t>
+            </a:r>
+          </a:p>
+        </p:txBody>
+      </p:sp>
+      <p:sp>
+        <p:nvSpPr>
+          <p:cNvPr id="57" name="Rectangle 56"/>
+          <p:cNvSpPr/>
+          <p:nvPr/>
+        </p:nvSpPr>
+        <p:spPr>
+          <a:xfrm>
+            <a:off x="566928" y="4320540"/>
+            <a:ext cx="11018519" cy="7315"/>
+          </a:xfrm>
+          <a:prstGeom prst="rect">
+            <a:avLst/>
+          </a:prstGeom>
+          <a:solidFill>
+            <a:srgbClr val="E7E9EB"/>
+          </a:solidFill>
+          <a:ln>
+            <a:noFill/>
+          </a:ln>
+        </p:spPr>
+        <p:style>
+          <a:lnRef idx="1">
+            <a:schemeClr val="accent1"/>
+          </a:lnRef>
+          <a:fillRef idx="3">
+            <a:schemeClr val="accent1"/>
+          </a:fillRef>
+          <a:effectRef idx="2">
+            <a:schemeClr val="accent1"/>
+          </a:effectRef>
+          <a:fontRef idx="minor">
+            <a:schemeClr val="lt1"/>
+          </a:fontRef>
+        </p:style>
+        <p:txBody>
+          <a:bodyPr rtlCol="0" anchor="ctr"/>
+          <a:lstStyle/>
+          <a:p>
+            <a:pPr algn="ctr"/>
+          </a:p>
+        </p:txBody>
+      </p:sp>
+      <p:sp>
+        <p:nvSpPr>
+          <p:cNvPr id="58" name="TextBox 57"/>
+          <p:cNvSpPr txBox="1"/>
+          <p:nvPr/>
+        </p:nvSpPr>
+        <p:spPr>
+          <a:xfrm>
+            <a:off x="566928" y="4366259"/>
+            <a:ext cx="640080" cy="274320"/>
+          </a:xfrm>
+          <a:prstGeom prst="rect">
+            <a:avLst/>
+          </a:prstGeom>
+          <a:noFill/>
+        </p:spPr>
+        <p:txBody>
+          <a:bodyPr wrap="square" anchor="t" lIns="0" rIns="0" tIns="0" bIns="0">
+            <a:spAutoFit/>
+          </a:bodyPr>
+          <a:lstStyle/>
+          <a:p>
+            <a:pPr algn="l">
+              <a:defRPr sz="1100" b="0">
+                <a:solidFill>
+                  <a:srgbClr val="30353A"/>
+                </a:solidFill>
+                <a:latin typeface="Arial"/>
+              </a:defRPr>
+            </a:pPr>
+            <a:r>
+              <a:t>5º</a:t>
+            </a:r>
+          </a:p>
+        </p:txBody>
+      </p:sp>
+      <p:sp>
+        <p:nvSpPr>
+          <p:cNvPr id="59" name="TextBox 58"/>
+          <p:cNvSpPr txBox="1"/>
+          <p:nvPr/>
+        </p:nvSpPr>
+        <p:spPr>
+          <a:xfrm>
+            <a:off x="1207007" y="4366259"/>
+            <a:ext cx="4572000" cy="274320"/>
+          </a:xfrm>
+          <a:prstGeom prst="rect">
+            <a:avLst/>
+          </a:prstGeom>
+          <a:noFill/>
+        </p:spPr>
+        <p:txBody>
+          <a:bodyPr wrap="square" anchor="t" lIns="0" rIns="0" tIns="0" bIns="0">
+            <a:spAutoFit/>
+          </a:bodyPr>
+          <a:lstStyle/>
+          <a:p>
+            <a:pPr algn="l">
+              <a:defRPr sz="1100" b="0">
+                <a:solidFill>
+                  <a:srgbClr val="30353A"/>
+                </a:solidFill>
+                <a:latin typeface="Arial"/>
+              </a:defRPr>
+            </a:pPr>
+            <a:r>
+              <a:t>Safra</a:t>
+            </a:r>
+          </a:p>
+        </p:txBody>
+      </p:sp>
+      <p:sp>
+        <p:nvSpPr>
+          <p:cNvPr id="60" name="TextBox 59"/>
+          <p:cNvSpPr txBox="1"/>
+          <p:nvPr/>
+        </p:nvSpPr>
+        <p:spPr>
+          <a:xfrm>
+            <a:off x="5779008" y="4366259"/>
+            <a:ext cx="2286000" cy="274320"/>
+          </a:xfrm>
+          <a:prstGeom prst="rect">
+            <a:avLst/>
+          </a:prstGeom>
+          <a:noFill/>
+        </p:spPr>
+        <p:txBody>
+          <a:bodyPr wrap="square" anchor="t" lIns="0" rIns="0" tIns="0" bIns="0">
+            <a:spAutoFit/>
+          </a:bodyPr>
+          <a:lstStyle/>
+          <a:p>
+            <a:pPr algn="r">
+              <a:defRPr sz="1100" b="0">
+                <a:solidFill>
+                  <a:srgbClr val="30353A"/>
+                </a:solidFill>
+                <a:latin typeface="Arial"/>
+              </a:defRPr>
+            </a:pPr>
+            <a:r>
+              <a:t>1,0</a:t>
+            </a:r>
+          </a:p>
+        </p:txBody>
+      </p:sp>
+      <p:sp>
+        <p:nvSpPr>
+          <p:cNvPr id="61" name="TextBox 60"/>
+          <p:cNvSpPr txBox="1"/>
+          <p:nvPr/>
+        </p:nvSpPr>
+        <p:spPr>
+          <a:xfrm>
+            <a:off x="8065007" y="4366259"/>
+            <a:ext cx="1737360" cy="274320"/>
+          </a:xfrm>
+          <a:prstGeom prst="rect">
+            <a:avLst/>
+          </a:prstGeom>
+          <a:noFill/>
+        </p:spPr>
+        <p:txBody>
+          <a:bodyPr wrap="square" anchor="t" lIns="0" rIns="0" tIns="0" bIns="0">
+            <a:spAutoFit/>
+          </a:bodyPr>
+          <a:lstStyle/>
+          <a:p>
+            <a:pPr algn="r">
+              <a:defRPr sz="1100" b="0">
+                <a:solidFill>
+                  <a:srgbClr val="30353A"/>
+                </a:solidFill>
+                <a:latin typeface="Arial"/>
+              </a:defRPr>
+            </a:pPr>
+            <a:r>
+              <a:t>4,1%</a:t>
+            </a:r>
+          </a:p>
+        </p:txBody>
+      </p:sp>
+      <p:sp>
+        <p:nvSpPr>
+          <p:cNvPr id="62" name="TextBox 61"/>
+          <p:cNvSpPr txBox="1"/>
+          <p:nvPr/>
+        </p:nvSpPr>
+        <p:spPr>
+          <a:xfrm>
+            <a:off x="9802367" y="4366259"/>
+            <a:ext cx="1783080" cy="274320"/>
+          </a:xfrm>
+          <a:prstGeom prst="rect">
+            <a:avLst/>
+          </a:prstGeom>
+          <a:noFill/>
+        </p:spPr>
+        <p:txBody>
+          <a:bodyPr wrap="square" anchor="t" lIns="0" rIns="0" tIns="0" bIns="0">
+            <a:spAutoFit/>
+          </a:bodyPr>
+          <a:lstStyle/>
+          <a:p>
+            <a:pPr algn="r">
+              <a:defRPr sz="1100" b="0">
+                <a:solidFill>
+                  <a:srgbClr val="30353A"/>
+                </a:solidFill>
+                <a:latin typeface="Arial"/>
+              </a:defRPr>
+            </a:pPr>
+            <a:r>
+              <a:t>1</a:t>
+            </a:r>
+          </a:p>
+        </p:txBody>
+      </p:sp>
+      <p:sp>
+        <p:nvSpPr>
+          <p:cNvPr id="63" name="Rectangle 62"/>
+          <p:cNvSpPr/>
+          <p:nvPr/>
+        </p:nvSpPr>
+        <p:spPr>
+          <a:xfrm>
+            <a:off x="566928" y="4594859"/>
+            <a:ext cx="11018519" cy="7315"/>
+          </a:xfrm>
+          <a:prstGeom prst="rect">
+            <a:avLst/>
+          </a:prstGeom>
+          <a:solidFill>
+            <a:srgbClr val="E7E9EB"/>
+          </a:solidFill>
+          <a:ln>
+            <a:noFill/>
+          </a:ln>
+        </p:spPr>
+        <p:style>
+          <a:lnRef idx="1">
+            <a:schemeClr val="accent1"/>
+          </a:lnRef>
+          <a:fillRef idx="3">
+            <a:schemeClr val="accent1"/>
+          </a:fillRef>
+          <a:effectRef idx="2">
+            <a:schemeClr val="accent1"/>
+          </a:effectRef>
+          <a:fontRef idx="minor">
+            <a:schemeClr val="lt1"/>
+          </a:fontRef>
+        </p:style>
+        <p:txBody>
+          <a:bodyPr rtlCol="0" anchor="ctr"/>
+          <a:lstStyle/>
+          <a:p>
+            <a:pPr algn="ctr"/>
+          </a:p>
+        </p:txBody>
+      </p:sp>
+      <p:sp>
+        <p:nvSpPr>
+          <p:cNvPr id="64" name="TextBox 63"/>
+          <p:cNvSpPr txBox="1"/>
+          <p:nvPr/>
+        </p:nvSpPr>
+        <p:spPr>
+          <a:xfrm>
+            <a:off x="566928" y="4640579"/>
+            <a:ext cx="640080" cy="274320"/>
+          </a:xfrm>
+          <a:prstGeom prst="rect">
+            <a:avLst/>
+          </a:prstGeom>
+          <a:noFill/>
+        </p:spPr>
+        <p:txBody>
+          <a:bodyPr wrap="square" anchor="t" lIns="0" rIns="0" tIns="0" bIns="0">
+            <a:spAutoFit/>
+          </a:bodyPr>
+          <a:lstStyle/>
+          <a:p>
+            <a:pPr algn="l">
+              <a:defRPr sz="1100" b="0">
+                <a:solidFill>
+                  <a:srgbClr val="30353A"/>
+                </a:solidFill>
+                <a:latin typeface="Arial"/>
+              </a:defRPr>
+            </a:pPr>
+            <a:r>
+              <a:t>7º</a:t>
+            </a:r>
+          </a:p>
+        </p:txBody>
+      </p:sp>
+      <p:sp>
+        <p:nvSpPr>
+          <p:cNvPr id="65" name="TextBox 64"/>
+          <p:cNvSpPr txBox="1"/>
+          <p:nvPr/>
+        </p:nvSpPr>
+        <p:spPr>
+          <a:xfrm>
+            <a:off x="1207007" y="4640579"/>
+            <a:ext cx="4572000" cy="274320"/>
+          </a:xfrm>
+          <a:prstGeom prst="rect">
+            <a:avLst/>
+          </a:prstGeom>
+          <a:noFill/>
+        </p:spPr>
+        <p:txBody>
+          <a:bodyPr wrap="square" anchor="t" lIns="0" rIns="0" tIns="0" bIns="0">
+            <a:spAutoFit/>
+          </a:bodyPr>
+          <a:lstStyle/>
+          <a:p>
+            <a:pPr algn="l">
+              <a:defRPr sz="1100" b="0">
+                <a:solidFill>
+                  <a:srgbClr val="30353A"/>
+                </a:solidFill>
+                <a:latin typeface="Arial"/>
+              </a:defRPr>
+            </a:pPr>
+            <a:r>
+              <a:t>XP Investimentos</a:t>
+            </a:r>
+          </a:p>
+        </p:txBody>
+      </p:sp>
+      <p:sp>
+        <p:nvSpPr>
+          <p:cNvPr id="66" name="TextBox 65"/>
+          <p:cNvSpPr txBox="1"/>
+          <p:nvPr/>
+        </p:nvSpPr>
+        <p:spPr>
+          <a:xfrm>
+            <a:off x="5779008" y="4640579"/>
+            <a:ext cx="2286000" cy="274320"/>
+          </a:xfrm>
+          <a:prstGeom prst="rect">
+            <a:avLst/>
+          </a:prstGeom>
+          <a:noFill/>
+        </p:spPr>
+        <p:txBody>
+          <a:bodyPr wrap="square" anchor="t" lIns="0" rIns="0" tIns="0" bIns="0">
+            <a:spAutoFit/>
+          </a:bodyPr>
+          <a:lstStyle/>
+          <a:p>
+            <a:pPr algn="r">
+              <a:defRPr sz="1100" b="0">
+                <a:solidFill>
+                  <a:srgbClr val="30353A"/>
+                </a:solidFill>
+                <a:latin typeface="Arial"/>
+              </a:defRPr>
+            </a:pPr>
+            <a:r>
+              <a:t>0,7</a:t>
+            </a:r>
+          </a:p>
+        </p:txBody>
+      </p:sp>
+      <p:sp>
+        <p:nvSpPr>
+          <p:cNvPr id="67" name="TextBox 66"/>
+          <p:cNvSpPr txBox="1"/>
+          <p:nvPr/>
+        </p:nvSpPr>
+        <p:spPr>
+          <a:xfrm>
+            <a:off x="8065007" y="4640579"/>
+            <a:ext cx="1737360" cy="274320"/>
+          </a:xfrm>
+          <a:prstGeom prst="rect">
+            <a:avLst/>
+          </a:prstGeom>
+          <a:noFill/>
+        </p:spPr>
+        <p:txBody>
+          <a:bodyPr wrap="square" anchor="t" lIns="0" rIns="0" tIns="0" bIns="0">
+            <a:spAutoFit/>
+          </a:bodyPr>
+          <a:lstStyle/>
+          <a:p>
+            <a:pPr algn="r">
+              <a:defRPr sz="1100" b="0">
+                <a:solidFill>
+                  <a:srgbClr val="30353A"/>
+                </a:solidFill>
+                <a:latin typeface="Arial"/>
+              </a:defRPr>
+            </a:pPr>
+            <a:r>
+              <a:t>2,9%</a:t>
+            </a:r>
+          </a:p>
+        </p:txBody>
+      </p:sp>
+      <p:sp>
+        <p:nvSpPr>
+          <p:cNvPr id="68" name="TextBox 67"/>
+          <p:cNvSpPr txBox="1"/>
+          <p:nvPr/>
+        </p:nvSpPr>
+        <p:spPr>
+          <a:xfrm>
+            <a:off x="9802367" y="4640579"/>
+            <a:ext cx="1783080" cy="274320"/>
+          </a:xfrm>
+          <a:prstGeom prst="rect">
+            <a:avLst/>
+          </a:prstGeom>
+          <a:noFill/>
+        </p:spPr>
+        <p:txBody>
+          <a:bodyPr wrap="square" anchor="t" lIns="0" rIns="0" tIns="0" bIns="0">
+            <a:spAutoFit/>
+          </a:bodyPr>
+          <a:lstStyle/>
+          <a:p>
+            <a:pPr algn="r">
+              <a:defRPr sz="1100" b="0">
+                <a:solidFill>
+                  <a:srgbClr val="30353A"/>
+                </a:solidFill>
+                <a:latin typeface="Arial"/>
+              </a:defRPr>
+            </a:pPr>
+            <a:r>
+              <a:t>2</a:t>
+            </a:r>
+          </a:p>
+        </p:txBody>
+      </p:sp>
+      <p:sp>
+        <p:nvSpPr>
+          <p:cNvPr id="69" name="Rectangle 68"/>
+          <p:cNvSpPr/>
+          <p:nvPr/>
+        </p:nvSpPr>
+        <p:spPr>
+          <a:xfrm>
+            <a:off x="566928" y="4869179"/>
+            <a:ext cx="11018519" cy="7315"/>
+          </a:xfrm>
+          <a:prstGeom prst="rect">
+            <a:avLst/>
+          </a:prstGeom>
+          <a:solidFill>
+            <a:srgbClr val="E7E9EB"/>
+          </a:solidFill>
+          <a:ln>
+            <a:noFill/>
+          </a:ln>
+        </p:spPr>
+        <p:style>
+          <a:lnRef idx="1">
+            <a:schemeClr val="accent1"/>
+          </a:lnRef>
+          <a:fillRef idx="3">
+            <a:schemeClr val="accent1"/>
+          </a:fillRef>
+          <a:effectRef idx="2">
+            <a:schemeClr val="accent1"/>
+          </a:effectRef>
+          <a:fontRef idx="minor">
+            <a:schemeClr val="lt1"/>
+          </a:fontRef>
+        </p:style>
+        <p:txBody>
+          <a:bodyPr rtlCol="0" anchor="ctr"/>
+          <a:lstStyle/>
+          <a:p>
+            <a:pPr algn="ctr"/>
+          </a:p>
+        </p:txBody>
+      </p:sp>
+      <p:sp>
+        <p:nvSpPr>
+          <p:cNvPr id="70" name="TextBox 69"/>
+          <p:cNvSpPr txBox="1"/>
+          <p:nvPr/>
+        </p:nvSpPr>
+        <p:spPr>
+          <a:xfrm>
+            <a:off x="566928" y="4914899"/>
+            <a:ext cx="640080" cy="274320"/>
+          </a:xfrm>
+          <a:prstGeom prst="rect">
+            <a:avLst/>
+          </a:prstGeom>
+          <a:noFill/>
+        </p:spPr>
+        <p:txBody>
+          <a:bodyPr wrap="square" anchor="t" lIns="0" rIns="0" tIns="0" bIns="0">
+            <a:spAutoFit/>
+          </a:bodyPr>
+          <a:lstStyle/>
+          <a:p>
+            <a:pPr algn="l">
+              <a:defRPr sz="1100" b="0">
+                <a:solidFill>
+                  <a:srgbClr val="30353A"/>
+                </a:solidFill>
+                <a:latin typeface="Arial"/>
+              </a:defRPr>
+            </a:pPr>
+            <a:r>
+              <a:t>8º</a:t>
+            </a:r>
+          </a:p>
+        </p:txBody>
+      </p:sp>
+      <p:sp>
+        <p:nvSpPr>
+          <p:cNvPr id="71" name="TextBox 70"/>
+          <p:cNvSpPr txBox="1"/>
+          <p:nvPr/>
+        </p:nvSpPr>
+        <p:spPr>
+          <a:xfrm>
+            <a:off x="1207007" y="4914899"/>
+            <a:ext cx="4572000" cy="274320"/>
+          </a:xfrm>
+          <a:prstGeom prst="rect">
+            <a:avLst/>
+          </a:prstGeom>
+          <a:noFill/>
+        </p:spPr>
+        <p:txBody>
+          <a:bodyPr wrap="square" anchor="t" lIns="0" rIns="0" tIns="0" bIns="0">
+            <a:spAutoFit/>
+          </a:bodyPr>
+          <a:lstStyle/>
+          <a:p>
+            <a:pPr algn="l">
+              <a:defRPr sz="1100" b="0">
+                <a:solidFill>
+                  <a:srgbClr val="30353A"/>
+                </a:solidFill>
+                <a:latin typeface="Arial"/>
+              </a:defRPr>
+            </a:pPr>
+            <a:r>
+              <a:t>Votorantim</a:t>
+            </a:r>
+          </a:p>
+        </p:txBody>
+      </p:sp>
+      <p:sp>
+        <p:nvSpPr>
+          <p:cNvPr id="72" name="TextBox 71"/>
+          <p:cNvSpPr txBox="1"/>
+          <p:nvPr/>
+        </p:nvSpPr>
+        <p:spPr>
+          <a:xfrm>
+            <a:off x="5779008" y="4914899"/>
+            <a:ext cx="2286000" cy="274320"/>
+          </a:xfrm>
+          <a:prstGeom prst="rect">
+            <a:avLst/>
+          </a:prstGeom>
+          <a:noFill/>
+        </p:spPr>
+        <p:txBody>
+          <a:bodyPr wrap="square" anchor="t" lIns="0" rIns="0" tIns="0" bIns="0">
+            <a:spAutoFit/>
+          </a:bodyPr>
+          <a:lstStyle/>
+          <a:p>
+            <a:pPr algn="r">
+              <a:defRPr sz="1100" b="0">
+                <a:solidFill>
+                  <a:srgbClr val="30353A"/>
+                </a:solidFill>
+                <a:latin typeface="Arial"/>
+              </a:defRPr>
+            </a:pPr>
+            <a:r>
+              <a:t>0,6</a:t>
+            </a:r>
+          </a:p>
+        </p:txBody>
+      </p:sp>
+      <p:sp>
+        <p:nvSpPr>
+          <p:cNvPr id="73" name="TextBox 72"/>
+          <p:cNvSpPr txBox="1"/>
+          <p:nvPr/>
+        </p:nvSpPr>
+        <p:spPr>
+          <a:xfrm>
+            <a:off x="8065007" y="4914899"/>
+            <a:ext cx="1737360" cy="274320"/>
+          </a:xfrm>
+          <a:prstGeom prst="rect">
+            <a:avLst/>
+          </a:prstGeom>
+          <a:noFill/>
+        </p:spPr>
+        <p:txBody>
+          <a:bodyPr wrap="square" anchor="t" lIns="0" rIns="0" tIns="0" bIns="0">
+            <a:spAutoFit/>
+          </a:bodyPr>
+          <a:lstStyle/>
+          <a:p>
+            <a:pPr algn="r">
+              <a:defRPr sz="1100" b="0">
+                <a:solidFill>
+                  <a:srgbClr val="30353A"/>
+                </a:solidFill>
+                <a:latin typeface="Arial"/>
+              </a:defRPr>
+            </a:pPr>
+            <a:r>
+              <a:t>2,5%</a:t>
+            </a:r>
+          </a:p>
+        </p:txBody>
+      </p:sp>
+      <p:sp>
+        <p:nvSpPr>
+          <p:cNvPr id="74" name="TextBox 73"/>
+          <p:cNvSpPr txBox="1"/>
+          <p:nvPr/>
+        </p:nvSpPr>
+        <p:spPr>
+          <a:xfrm>
+            <a:off x="9802367" y="4914899"/>
+            <a:ext cx="1783080" cy="274320"/>
+          </a:xfrm>
+          <a:prstGeom prst="rect">
+            <a:avLst/>
+          </a:prstGeom>
+          <a:noFill/>
+        </p:spPr>
+        <p:txBody>
+          <a:bodyPr wrap="square" anchor="t" lIns="0" rIns="0" tIns="0" bIns="0">
+            <a:spAutoFit/>
+          </a:bodyPr>
+          <a:lstStyle/>
+          <a:p>
+            <a:pPr algn="r">
+              <a:defRPr sz="1100" b="0">
+                <a:solidFill>
+                  <a:srgbClr val="30353A"/>
+                </a:solidFill>
+                <a:latin typeface="Arial"/>
+              </a:defRPr>
+            </a:pPr>
+            <a:r>
+              <a:t>4</a:t>
+            </a:r>
+          </a:p>
+        </p:txBody>
+      </p:sp>
+      <p:sp>
+        <p:nvSpPr>
+          <p:cNvPr id="75" name="Rectangle 74"/>
+          <p:cNvSpPr/>
+          <p:nvPr/>
+        </p:nvSpPr>
+        <p:spPr>
+          <a:xfrm>
+            <a:off x="566928" y="5143499"/>
+            <a:ext cx="11018519" cy="7315"/>
+          </a:xfrm>
+          <a:prstGeom prst="rect">
+            <a:avLst/>
+          </a:prstGeom>
+          <a:solidFill>
+            <a:srgbClr val="E7E9EB"/>
+          </a:solidFill>
+          <a:ln>
+            <a:noFill/>
+          </a:ln>
+        </p:spPr>
+        <p:style>
+          <a:lnRef idx="1">
+            <a:schemeClr val="accent1"/>
+          </a:lnRef>
+          <a:fillRef idx="3">
+            <a:schemeClr val="accent1"/>
+          </a:fillRef>
+          <a:effectRef idx="2">
+            <a:schemeClr val="accent1"/>
+          </a:effectRef>
+          <a:fontRef idx="minor">
+            <a:schemeClr val="lt1"/>
+          </a:fontRef>
+        </p:style>
+        <p:txBody>
+          <a:bodyPr rtlCol="0" anchor="ctr"/>
+          <a:lstStyle/>
+          <a:p>
+            <a:pPr algn="ctr"/>
+          </a:p>
+        </p:txBody>
+      </p:sp>
+      <p:sp>
+        <p:nvSpPr>
+          <p:cNvPr id="76" name="TextBox 75"/>
+          <p:cNvSpPr txBox="1"/>
+          <p:nvPr/>
+        </p:nvSpPr>
+        <p:spPr>
+          <a:xfrm>
+            <a:off x="566928" y="5189219"/>
+            <a:ext cx="640080" cy="274320"/>
+          </a:xfrm>
+          <a:prstGeom prst="rect">
+            <a:avLst/>
+          </a:prstGeom>
+          <a:noFill/>
+        </p:spPr>
+        <p:txBody>
+          <a:bodyPr wrap="square" anchor="t" lIns="0" rIns="0" tIns="0" bIns="0">
+            <a:spAutoFit/>
+          </a:bodyPr>
+          <a:lstStyle/>
+          <a:p>
+            <a:pPr algn="l">
+              <a:defRPr sz="1100" b="0">
+                <a:solidFill>
+                  <a:srgbClr val="30353A"/>
+                </a:solidFill>
+                <a:latin typeface="Arial"/>
+              </a:defRPr>
+            </a:pPr>
+            <a:r>
+              <a:t>9º</a:t>
+            </a:r>
+          </a:p>
+        </p:txBody>
+      </p:sp>
+      <p:sp>
+        <p:nvSpPr>
+          <p:cNvPr id="77" name="TextBox 76"/>
+          <p:cNvSpPr txBox="1"/>
+          <p:nvPr/>
+        </p:nvSpPr>
+        <p:spPr>
+          <a:xfrm>
+            <a:off x="1207007" y="5189219"/>
+            <a:ext cx="4572000" cy="274320"/>
+          </a:xfrm>
+          <a:prstGeom prst="rect">
+            <a:avLst/>
+          </a:prstGeom>
+          <a:noFill/>
+        </p:spPr>
+        <p:txBody>
+          <a:bodyPr wrap="square" anchor="t" lIns="0" rIns="0" tIns="0" bIns="0">
+            <a:spAutoFit/>
+          </a:bodyPr>
+          <a:lstStyle/>
+          <a:p>
+            <a:pPr algn="l">
+              <a:defRPr sz="1100" b="0">
+                <a:solidFill>
+                  <a:srgbClr val="30353A"/>
+                </a:solidFill>
+                <a:latin typeface="Arial"/>
+              </a:defRPr>
+            </a:pPr>
+            <a:r>
+              <a:t>BR Partners</a:t>
+            </a:r>
+          </a:p>
+        </p:txBody>
+      </p:sp>
+      <p:sp>
+        <p:nvSpPr>
+          <p:cNvPr id="78" name="TextBox 77"/>
+          <p:cNvSpPr txBox="1"/>
+          <p:nvPr/>
+        </p:nvSpPr>
+        <p:spPr>
+          <a:xfrm>
+            <a:off x="5779008" y="5189219"/>
+            <a:ext cx="2286000" cy="274320"/>
+          </a:xfrm>
+          <a:prstGeom prst="rect">
+            <a:avLst/>
+          </a:prstGeom>
+          <a:noFill/>
+        </p:spPr>
+        <p:txBody>
+          <a:bodyPr wrap="square" anchor="t" lIns="0" rIns="0" tIns="0" bIns="0">
+            <a:spAutoFit/>
+          </a:bodyPr>
+          <a:lstStyle/>
+          <a:p>
+            <a:pPr algn="r">
+              <a:defRPr sz="1100" b="0">
+                <a:solidFill>
+                  <a:srgbClr val="30353A"/>
+                </a:solidFill>
+                <a:latin typeface="Arial"/>
+              </a:defRPr>
+            </a:pPr>
+            <a:r>
+              <a:t>0,5</a:t>
+            </a:r>
+          </a:p>
+        </p:txBody>
+      </p:sp>
+      <p:sp>
+        <p:nvSpPr>
+          <p:cNvPr id="79" name="TextBox 78"/>
+          <p:cNvSpPr txBox="1"/>
+          <p:nvPr/>
+        </p:nvSpPr>
+        <p:spPr>
+          <a:xfrm>
+            <a:off x="8065007" y="5189219"/>
+            <a:ext cx="1737360" cy="274320"/>
+          </a:xfrm>
+          <a:prstGeom prst="rect">
+            <a:avLst/>
+          </a:prstGeom>
+          <a:noFill/>
+        </p:spPr>
+        <p:txBody>
+          <a:bodyPr wrap="square" anchor="t" lIns="0" rIns="0" tIns="0" bIns="0">
+            <a:spAutoFit/>
+          </a:bodyPr>
+          <a:lstStyle/>
+          <a:p>
+            <a:pPr algn="r">
+              <a:defRPr sz="1100" b="0">
+                <a:solidFill>
+                  <a:srgbClr val="30353A"/>
+                </a:solidFill>
+                <a:latin typeface="Arial"/>
+              </a:defRPr>
+            </a:pPr>
+            <a:r>
+              <a:t>2,1%</a:t>
+            </a:r>
+          </a:p>
+        </p:txBody>
+      </p:sp>
+      <p:sp>
+        <p:nvSpPr>
+          <p:cNvPr id="80" name="TextBox 79"/>
+          <p:cNvSpPr txBox="1"/>
+          <p:nvPr/>
+        </p:nvSpPr>
+        <p:spPr>
+          <a:xfrm>
+            <a:off x="9802367" y="5189219"/>
+            <a:ext cx="1783080" cy="274320"/>
+          </a:xfrm>
+          <a:prstGeom prst="rect">
+            <a:avLst/>
+          </a:prstGeom>
+          <a:noFill/>
+        </p:spPr>
+        <p:txBody>
+          <a:bodyPr wrap="square" anchor="t" lIns="0" rIns="0" tIns="0" bIns="0">
+            <a:spAutoFit/>
+          </a:bodyPr>
+          <a:lstStyle/>
+          <a:p>
+            <a:pPr algn="r">
+              <a:defRPr sz="1100" b="0">
+                <a:solidFill>
+                  <a:srgbClr val="30353A"/>
+                </a:solidFill>
+                <a:latin typeface="Arial"/>
+              </a:defRPr>
+            </a:pPr>
+            <a:r>
+              <a:t>5</a:t>
+            </a:r>
+          </a:p>
+        </p:txBody>
+      </p:sp>
+      <p:sp>
+        <p:nvSpPr>
+          <p:cNvPr id="81" name="TextBox 80"/>
+          <p:cNvSpPr txBox="1"/>
+          <p:nvPr/>
+        </p:nvSpPr>
+        <p:spPr>
+          <a:xfrm>
+            <a:off x="566928" y="5701283"/>
+            <a:ext cx="11018520" cy="566928"/>
+          </a:xfrm>
+          <a:prstGeom prst="rect">
+            <a:avLst/>
+          </a:prstGeom>
+          <a:noFill/>
+        </p:spPr>
+        <p:txBody>
+          <a:bodyPr wrap="square" anchor="t" lIns="0" rIns="0" tIns="0" bIns="0">
+            <a:spAutoFit/>
+          </a:bodyPr>
+          <a:lstStyle/>
+          <a:p>
+            <a:pPr algn="l">
+              <a:defRPr sz="1100" b="0">
+                <a:solidFill>
+                  <a:srgbClr val="5D6369"/>
+                </a:solidFill>
+                <a:latin typeface="Arial"/>
+              </a:defRPr>
+            </a:pPr>
+            <a:r>
+              <a:t>Na distribuição — o esforço efetivo de colocação — o Itaú BBA também é 1º, com 42,5%. O mercado apurado de FIDC no ranking é de R$ 25,1 bi, contra R$ 65,5 bi de cotas de FIDC registradas na CVM no mesmo período: o ranking cobre a parcela disputada, sem as operações de empresas ligadas e sem as ofertas não reportadas à ANBIMA.</a:t>
+            </a:r>
+          </a:p>
+        </p:txBody>
+      </p:sp>
+      <p:sp>
+        <p:nvSpPr>
+          <p:cNvPr id="82" name="Rectangle 81"/>
+          <p:cNvSpPr/>
+          <p:nvPr/>
+        </p:nvSpPr>
+        <p:spPr>
+          <a:xfrm>
+            <a:off x="566928" y="6355080"/>
+            <a:ext cx="11018520" cy="9144"/>
+          </a:xfrm>
+          <a:prstGeom prst="rect">
+            <a:avLst/>
+          </a:prstGeom>
+          <a:solidFill>
+            <a:srgbClr val="E7E9EB"/>
+          </a:solidFill>
+          <a:ln>
+            <a:noFill/>
+          </a:ln>
+        </p:spPr>
+        <p:style>
+          <a:lnRef idx="1">
+            <a:schemeClr val="accent1"/>
+          </a:lnRef>
+          <a:fillRef idx="3">
+            <a:schemeClr val="accent1"/>
+          </a:fillRef>
+          <a:effectRef idx="2">
+            <a:schemeClr val="accent1"/>
+          </a:effectRef>
+          <a:fontRef idx="minor">
+            <a:schemeClr val="lt1"/>
+          </a:fontRef>
+        </p:style>
+        <p:txBody>
+          <a:bodyPr rtlCol="0" anchor="ctr"/>
+          <a:lstStyle/>
+          <a:p>
+            <a:pPr algn="ctr"/>
+          </a:p>
+        </p:txBody>
+      </p:sp>
+      <p:sp>
+        <p:nvSpPr>
+          <p:cNvPr id="83" name="TextBox 82"/>
           <p:cNvSpPr txBox="1"/>
           <p:nvPr/>
         </p:nvSpPr>
@@ -9090,14 +11270,14 @@
               </a:defRPr>
             </a:pPr>
             <a:r>
-              <a:t>Fonte: ANBIMA, Metodologia do Ranking de Renda Fixa e Híbridos (fev/2026), capítulos II a VII</a:t>
-            </a:r>
-          </a:p>
-        </p:txBody>
-      </p:sp>
-      <p:sp>
-        <p:nvSpPr>
-          <p:cNvPr id="25" name="TextBox 24"/>
+              <a:t>Fonte: ANBIMA, Ranking de Renda Fixa e Híbridos — Originação e Distribuição (Valor), Tipo 1.3.1, acumulado 2026 · CVM, ofertas públicas de distribuição</a:t>
+            </a:r>
+          </a:p>
+        </p:txBody>
+      </p:sp>
+      <p:sp>
+        <p:nvSpPr>
+          <p:cNvPr id="84" name="TextBox 83"/>
           <p:cNvSpPr txBox="1"/>
           <p:nvPr/>
         </p:nvSpPr>
@@ -9224,7 +11404,7 @@
               </a:defRPr>
             </a:pPr>
             <a:r>
-              <a:t>Fontes, reprodutibilidade e ressalvas</a:t>
+              <a:t>Como a ANBIMA apura o ranking</a:t>
             </a:r>
           </a:p>
         </p:txBody>
@@ -9274,14 +11454,851 @@
       </p:sp>
       <p:sp>
         <p:nvSpPr>
-          <p:cNvPr id="5" name="TextBox 4"/>
-          <p:cNvSpPr txBox="1"/>
+          <p:cNvPr id="5" name="Rectangle 4"/>
+          <p:cNvSpPr/>
           <p:nvPr/>
         </p:nvSpPr>
         <p:spPr>
           <a:xfrm>
             <a:off x="566928" y="1371600"/>
-            <a:ext cx="2834640" cy="347472"/>
+            <a:ext cx="41148" cy="969264"/>
+          </a:xfrm>
+          <a:prstGeom prst="rect">
+            <a:avLst/>
+          </a:prstGeom>
+          <a:solidFill>
+            <a:srgbClr val="E36C0A"/>
+          </a:solidFill>
+          <a:ln>
+            <a:noFill/>
+          </a:ln>
+          <a:effectLst/>
+        </p:spPr>
+        <p:style>
+          <a:lnRef idx="1">
+            <a:schemeClr val="accent1"/>
+          </a:lnRef>
+          <a:fillRef idx="3">
+            <a:schemeClr val="accent1"/>
+          </a:fillRef>
+          <a:effectRef idx="2">
+            <a:schemeClr val="accent1"/>
+          </a:effectRef>
+          <a:fontRef idx="minor">
+            <a:schemeClr val="lt1"/>
+          </a:fontRef>
+        </p:style>
+        <p:txBody>
+          <a:bodyPr rtlCol="0" anchor="ctr"/>
+          <a:lstStyle/>
+          <a:p>
+            <a:pPr algn="ctr"/>
+          </a:p>
+        </p:txBody>
+      </p:sp>
+      <p:sp>
+        <p:nvSpPr>
+          <p:cNvPr id="6" name="TextBox 5"/>
+          <p:cNvSpPr txBox="1"/>
+          <p:nvPr/>
+        </p:nvSpPr>
+        <p:spPr>
+          <a:xfrm>
+            <a:off x="822960" y="1371600"/>
+            <a:ext cx="5029200" cy="457200"/>
+          </a:xfrm>
+          <a:prstGeom prst="rect">
+            <a:avLst/>
+          </a:prstGeom>
+          <a:noFill/>
+        </p:spPr>
+        <p:txBody>
+          <a:bodyPr wrap="square" anchor="t" lIns="0" rIns="0" tIns="0" bIns="0">
+            <a:spAutoFit/>
+          </a:bodyPr>
+          <a:lstStyle/>
+          <a:p>
+            <a:pPr algn="l">
+              <a:defRPr sz="1300" b="1">
+                <a:solidFill>
+                  <a:srgbClr val="151515"/>
+                </a:solidFill>
+                <a:latin typeface="Arial"/>
+              </a:defRPr>
+            </a:pPr>
+            <a:r>
+              <a:t>O ranking credita todos os coordenadores, não só o líder</a:t>
+            </a:r>
+          </a:p>
+        </p:txBody>
+      </p:sp>
+      <p:sp>
+        <p:nvSpPr>
+          <p:cNvPr id="7" name="TextBox 6"/>
+          <p:cNvSpPr txBox="1"/>
+          <p:nvPr/>
+        </p:nvSpPr>
+        <p:spPr>
+          <a:xfrm>
+            <a:off x="822960" y="1792224"/>
+            <a:ext cx="5029200" cy="868680"/>
+          </a:xfrm>
+          <a:prstGeom prst="rect">
+            <a:avLst/>
+          </a:prstGeom>
+          <a:noFill/>
+        </p:spPr>
+        <p:txBody>
+          <a:bodyPr wrap="square" anchor="t" lIns="0" rIns="0" tIns="0" bIns="0">
+            <a:spAutoFit/>
+          </a:bodyPr>
+          <a:lstStyle/>
+          <a:p>
+            <a:pPr algn="l">
+              <a:defRPr sz="1100" b="0">
+                <a:solidFill>
+                  <a:srgbClr val="5D6369"/>
+                </a:solidFill>
+                <a:latin typeface="Arial"/>
+              </a:defRPr>
+            </a:pPr>
+            <a:r>
+              <a:t>Cada coordenador e coordenador contratado recebe a fatia que lhe cabe na operação. O líder apenas reporta a operação à ANBIMA.</a:t>
+            </a:r>
+          </a:p>
+        </p:txBody>
+      </p:sp>
+      <p:sp>
+        <p:nvSpPr>
+          <p:cNvPr id="8" name="Rectangle 7"/>
+          <p:cNvSpPr/>
+          <p:nvPr/>
+        </p:nvSpPr>
+        <p:spPr>
+          <a:xfrm>
+            <a:off x="6236208" y="1371600"/>
+            <a:ext cx="41148" cy="969264"/>
+          </a:xfrm>
+          <a:prstGeom prst="rect">
+            <a:avLst/>
+          </a:prstGeom>
+          <a:solidFill>
+            <a:srgbClr val="E36C0A"/>
+          </a:solidFill>
+          <a:ln>
+            <a:noFill/>
+          </a:ln>
+          <a:effectLst/>
+        </p:spPr>
+        <p:style>
+          <a:lnRef idx="1">
+            <a:schemeClr val="accent1"/>
+          </a:lnRef>
+          <a:fillRef idx="3">
+            <a:schemeClr val="accent1"/>
+          </a:fillRef>
+          <a:effectRef idx="2">
+            <a:schemeClr val="accent1"/>
+          </a:effectRef>
+          <a:fontRef idx="minor">
+            <a:schemeClr val="lt1"/>
+          </a:fontRef>
+        </p:style>
+        <p:txBody>
+          <a:bodyPr rtlCol="0" anchor="ctr"/>
+          <a:lstStyle/>
+          <a:p>
+            <a:pPr algn="ctr"/>
+          </a:p>
+        </p:txBody>
+      </p:sp>
+      <p:sp>
+        <p:nvSpPr>
+          <p:cNvPr id="9" name="TextBox 8"/>
+          <p:cNvSpPr txBox="1"/>
+          <p:nvPr/>
+        </p:nvSpPr>
+        <p:spPr>
+          <a:xfrm>
+            <a:off x="6492240" y="1371600"/>
+            <a:ext cx="5029200" cy="457200"/>
+          </a:xfrm>
+          <a:prstGeom prst="rect">
+            <a:avLst/>
+          </a:prstGeom>
+          <a:noFill/>
+        </p:spPr>
+        <p:txBody>
+          <a:bodyPr wrap="square" anchor="t" lIns="0" rIns="0" tIns="0" bIns="0">
+            <a:spAutoFit/>
+          </a:bodyPr>
+          <a:lstStyle/>
+          <a:p>
+            <a:pPr algn="l">
+              <a:defRPr sz="1300" b="1">
+                <a:solidFill>
+                  <a:srgbClr val="151515"/>
+                </a:solidFill>
+                <a:latin typeface="Arial"/>
+              </a:defRPr>
+            </a:pPr>
+            <a:r>
+              <a:t>O rateio é contratual</a:t>
+            </a:r>
+          </a:p>
+        </p:txBody>
+      </p:sp>
+      <p:sp>
+        <p:nvSpPr>
+          <p:cNvPr id="10" name="TextBox 9"/>
+          <p:cNvSpPr txBox="1"/>
+          <p:nvPr/>
+        </p:nvSpPr>
+        <p:spPr>
+          <a:xfrm>
+            <a:off x="6492240" y="1792224"/>
+            <a:ext cx="5029200" cy="868680"/>
+          </a:xfrm>
+          <a:prstGeom prst="rect">
+            <a:avLst/>
+          </a:prstGeom>
+          <a:noFill/>
+        </p:spPr>
+        <p:txBody>
+          <a:bodyPr wrap="square" anchor="t" lIns="0" rIns="0" tIns="0" bIns="0">
+            <a:spAutoFit/>
+          </a:bodyPr>
+          <a:lstStyle/>
+          <a:p>
+            <a:pPr algn="l">
+              <a:defRPr sz="1100" b="0">
+                <a:solidFill>
+                  <a:srgbClr val="5D6369"/>
+                </a:solidFill>
+                <a:latin typeface="Arial"/>
+              </a:defRPr>
+            </a:pPr>
+            <a:r>
+              <a:t>Garantia firme: proporção da garantia definida em contrato. Melhores esforços: proporção do fee de coordenação e/ou estruturação.</a:t>
+            </a:r>
+          </a:p>
+        </p:txBody>
+      </p:sp>
+      <p:sp>
+        <p:nvSpPr>
+          <p:cNvPr id="11" name="Rectangle 10"/>
+          <p:cNvSpPr/>
+          <p:nvPr/>
+        </p:nvSpPr>
+        <p:spPr>
+          <a:xfrm>
+            <a:off x="566928" y="2944368"/>
+            <a:ext cx="41148" cy="969264"/>
+          </a:xfrm>
+          <a:prstGeom prst="rect">
+            <a:avLst/>
+          </a:prstGeom>
+          <a:solidFill>
+            <a:srgbClr val="E36C0A"/>
+          </a:solidFill>
+          <a:ln>
+            <a:noFill/>
+          </a:ln>
+          <a:effectLst/>
+        </p:spPr>
+        <p:style>
+          <a:lnRef idx="1">
+            <a:schemeClr val="accent1"/>
+          </a:lnRef>
+          <a:fillRef idx="3">
+            <a:schemeClr val="accent1"/>
+          </a:fillRef>
+          <a:effectRef idx="2">
+            <a:schemeClr val="accent1"/>
+          </a:effectRef>
+          <a:fontRef idx="minor">
+            <a:schemeClr val="lt1"/>
+          </a:fontRef>
+        </p:style>
+        <p:txBody>
+          <a:bodyPr rtlCol="0" anchor="ctr"/>
+          <a:lstStyle/>
+          <a:p>
+            <a:pPr algn="ctr"/>
+          </a:p>
+        </p:txBody>
+      </p:sp>
+      <p:sp>
+        <p:nvSpPr>
+          <p:cNvPr id="12" name="TextBox 11"/>
+          <p:cNvSpPr txBox="1"/>
+          <p:nvPr/>
+        </p:nvSpPr>
+        <p:spPr>
+          <a:xfrm>
+            <a:off x="822960" y="2944368"/>
+            <a:ext cx="5029200" cy="457200"/>
+          </a:xfrm>
+          <a:prstGeom prst="rect">
+            <a:avLst/>
+          </a:prstGeom>
+          <a:noFill/>
+        </p:spPr>
+        <p:txBody>
+          <a:bodyPr wrap="square" anchor="t" lIns="0" rIns="0" tIns="0" bIns="0">
+            <a:spAutoFit/>
+          </a:bodyPr>
+          <a:lstStyle/>
+          <a:p>
+            <a:pPr algn="l">
+              <a:defRPr sz="1300" b="1">
+                <a:solidFill>
+                  <a:srgbClr val="151515"/>
+                </a:solidFill>
+                <a:latin typeface="Arial"/>
+              </a:defRPr>
+            </a:pPr>
+            <a:r>
+              <a:t>O mês de referência é o do anúncio de encerramento</a:t>
+            </a:r>
+          </a:p>
+        </p:txBody>
+      </p:sp>
+      <p:sp>
+        <p:nvSpPr>
+          <p:cNvPr id="13" name="TextBox 12"/>
+          <p:cNvSpPr txBox="1"/>
+          <p:nvPr/>
+        </p:nvSpPr>
+        <p:spPr>
+          <a:xfrm>
+            <a:off x="822960" y="3364991"/>
+            <a:ext cx="5029200" cy="868680"/>
+          </a:xfrm>
+          <a:prstGeom prst="rect">
+            <a:avLst/>
+          </a:prstGeom>
+          <a:noFill/>
+        </p:spPr>
+        <p:txBody>
+          <a:bodyPr wrap="square" anchor="t" lIns="0" rIns="0" tIns="0" bIns="0">
+            <a:spAutoFit/>
+          </a:bodyPr>
+          <a:lstStyle/>
+          <a:p>
+            <a:pPr algn="l">
+              <a:defRPr sz="1100" b="0">
+                <a:solidFill>
+                  <a:srgbClr val="5D6369"/>
+                </a:solidFill>
+                <a:latin typeface="Arial"/>
+              </a:defRPr>
+            </a:pPr>
+            <a:r>
+              <a:t>Não é a data de registro nem a de emissão. Operações fora do prazo de envio escorregam para o ranking do trimestre seguinte.</a:t>
+            </a:r>
+          </a:p>
+        </p:txBody>
+      </p:sp>
+      <p:sp>
+        <p:nvSpPr>
+          <p:cNvPr id="14" name="Rectangle 13"/>
+          <p:cNvSpPr/>
+          <p:nvPr/>
+        </p:nvSpPr>
+        <p:spPr>
+          <a:xfrm>
+            <a:off x="6236208" y="2944368"/>
+            <a:ext cx="41148" cy="969264"/>
+          </a:xfrm>
+          <a:prstGeom prst="rect">
+            <a:avLst/>
+          </a:prstGeom>
+          <a:solidFill>
+            <a:srgbClr val="E36C0A"/>
+          </a:solidFill>
+          <a:ln>
+            <a:noFill/>
+          </a:ln>
+          <a:effectLst/>
+        </p:spPr>
+        <p:style>
+          <a:lnRef idx="1">
+            <a:schemeClr val="accent1"/>
+          </a:lnRef>
+          <a:fillRef idx="3">
+            <a:schemeClr val="accent1"/>
+          </a:fillRef>
+          <a:effectRef idx="2">
+            <a:schemeClr val="accent1"/>
+          </a:effectRef>
+          <a:fontRef idx="minor">
+            <a:schemeClr val="lt1"/>
+          </a:fontRef>
+        </p:style>
+        <p:txBody>
+          <a:bodyPr rtlCol="0" anchor="ctr"/>
+          <a:lstStyle/>
+          <a:p>
+            <a:pPr algn="ctr"/>
+          </a:p>
+        </p:txBody>
+      </p:sp>
+      <p:sp>
+        <p:nvSpPr>
+          <p:cNvPr id="15" name="TextBox 14"/>
+          <p:cNvSpPr txBox="1"/>
+          <p:nvPr/>
+        </p:nvSpPr>
+        <p:spPr>
+          <a:xfrm>
+            <a:off x="6492240" y="2944368"/>
+            <a:ext cx="5029200" cy="457200"/>
+          </a:xfrm>
+          <a:prstGeom prst="rect">
+            <a:avLst/>
+          </a:prstGeom>
+          <a:noFill/>
+        </p:spPr>
+        <p:txBody>
+          <a:bodyPr wrap="square" anchor="t" lIns="0" rIns="0" tIns="0" bIns="0">
+            <a:spAutoFit/>
+          </a:bodyPr>
+          <a:lstStyle/>
+          <a:p>
+            <a:pPr algn="l">
+              <a:defRPr sz="1300" b="1">
+                <a:solidFill>
+                  <a:srgbClr val="151515"/>
+                </a:solidFill>
+                <a:latin typeface="Arial"/>
+              </a:defRPr>
+            </a:pPr>
+            <a:r>
+              <a:t>É um ranking declaratório</a:t>
+            </a:r>
+          </a:p>
+        </p:txBody>
+      </p:sp>
+      <p:sp>
+        <p:nvSpPr>
+          <p:cNvPr id="16" name="TextBox 15"/>
+          <p:cNvSpPr txBox="1"/>
+          <p:nvPr/>
+        </p:nvSpPr>
+        <p:spPr>
+          <a:xfrm>
+            <a:off x="6492240" y="3364991"/>
+            <a:ext cx="5029200" cy="868680"/>
+          </a:xfrm>
+          <a:prstGeom prst="rect">
+            <a:avLst/>
+          </a:prstGeom>
+          <a:noFill/>
+        </p:spPr>
+        <p:txBody>
+          <a:bodyPr wrap="square" anchor="t" lIns="0" rIns="0" tIns="0" bIns="0">
+            <a:spAutoFit/>
+          </a:bodyPr>
+          <a:lstStyle/>
+          <a:p>
+            <a:pPr algn="l">
+              <a:defRPr sz="1100" b="0">
+                <a:solidFill>
+                  <a:srgbClr val="5D6369"/>
+                </a:solidFill>
+                <a:latin typeface="Arial"/>
+              </a:defRPr>
+            </a:pPr>
+            <a:r>
+              <a:t>Operação cujo formulário-padrão não foi enviado não entra. Boa parte do mercado liderado por administradores e DTVMs fica de fora.</a:t>
+            </a:r>
+          </a:p>
+        </p:txBody>
+      </p:sp>
+      <p:sp>
+        <p:nvSpPr>
+          <p:cNvPr id="17" name="Rectangle 16"/>
+          <p:cNvSpPr/>
+          <p:nvPr/>
+        </p:nvSpPr>
+        <p:spPr>
+          <a:xfrm>
+            <a:off x="566928" y="4517136"/>
+            <a:ext cx="41148" cy="969264"/>
+          </a:xfrm>
+          <a:prstGeom prst="rect">
+            <a:avLst/>
+          </a:prstGeom>
+          <a:solidFill>
+            <a:srgbClr val="E36C0A"/>
+          </a:solidFill>
+          <a:ln>
+            <a:noFill/>
+          </a:ln>
+          <a:effectLst/>
+        </p:spPr>
+        <p:style>
+          <a:lnRef idx="1">
+            <a:schemeClr val="accent1"/>
+          </a:lnRef>
+          <a:fillRef idx="3">
+            <a:schemeClr val="accent1"/>
+          </a:fillRef>
+          <a:effectRef idx="2">
+            <a:schemeClr val="accent1"/>
+          </a:effectRef>
+          <a:fontRef idx="minor">
+            <a:schemeClr val="lt1"/>
+          </a:fontRef>
+        </p:style>
+        <p:txBody>
+          <a:bodyPr rtlCol="0" anchor="ctr"/>
+          <a:lstStyle/>
+          <a:p>
+            <a:pPr algn="ctr"/>
+          </a:p>
+        </p:txBody>
+      </p:sp>
+      <p:sp>
+        <p:nvSpPr>
+          <p:cNvPr id="18" name="TextBox 17"/>
+          <p:cNvSpPr txBox="1"/>
+          <p:nvPr/>
+        </p:nvSpPr>
+        <p:spPr>
+          <a:xfrm>
+            <a:off x="822960" y="4517136"/>
+            <a:ext cx="5029200" cy="457200"/>
+          </a:xfrm>
+          <a:prstGeom prst="rect">
+            <a:avLst/>
+          </a:prstGeom>
+          <a:noFill/>
+        </p:spPr>
+        <p:txBody>
+          <a:bodyPr wrap="square" anchor="t" lIns="0" rIns="0" tIns="0" bIns="0">
+            <a:spAutoFit/>
+          </a:bodyPr>
+          <a:lstStyle/>
+          <a:p>
+            <a:pPr algn="l">
+              <a:defRPr sz="1300" b="1">
+                <a:solidFill>
+                  <a:srgbClr val="151515"/>
+                </a:solidFill>
+                <a:latin typeface="Arial"/>
+              </a:defRPr>
+            </a:pPr>
+            <a:r>
+              <a:t>Operações de empresas ligadas saem do Tipo 1</a:t>
+            </a:r>
+          </a:p>
+        </p:txBody>
+      </p:sp>
+      <p:sp>
+        <p:nvSpPr>
+          <p:cNvPr id="19" name="TextBox 18"/>
+          <p:cNvSpPr txBox="1"/>
+          <p:nvPr/>
+        </p:nvSpPr>
+        <p:spPr>
+          <a:xfrm>
+            <a:off x="822960" y="4937759"/>
+            <a:ext cx="5029200" cy="868680"/>
+          </a:xfrm>
+          <a:prstGeom prst="rect">
+            <a:avLst/>
+          </a:prstGeom>
+          <a:noFill/>
+        </p:spPr>
+        <p:txBody>
+          <a:bodyPr wrap="square" anchor="t" lIns="0" rIns="0" tIns="0" bIns="0">
+            <a:spAutoFit/>
+          </a:bodyPr>
+          <a:lstStyle/>
+          <a:p>
+            <a:pPr algn="l">
+              <a:defRPr sz="1100" b="0">
+                <a:solidFill>
+                  <a:srgbClr val="5D6369"/>
+                </a:solidFill>
+                <a:latin typeface="Arial"/>
+              </a:defRPr>
+            </a:pPr>
+            <a:r>
+              <a:t>Coordenador com participação de 10% ou mais na emissora, cedente ou originadora vai para o Tipo 3, apurado à parte.</a:t>
+            </a:r>
+          </a:p>
+        </p:txBody>
+      </p:sp>
+      <p:sp>
+        <p:nvSpPr>
+          <p:cNvPr id="20" name="Rectangle 19"/>
+          <p:cNvSpPr/>
+          <p:nvPr/>
+        </p:nvSpPr>
+        <p:spPr>
+          <a:xfrm>
+            <a:off x="6236208" y="4517136"/>
+            <a:ext cx="41148" cy="969264"/>
+          </a:xfrm>
+          <a:prstGeom prst="rect">
+            <a:avLst/>
+          </a:prstGeom>
+          <a:solidFill>
+            <a:srgbClr val="E36C0A"/>
+          </a:solidFill>
+          <a:ln>
+            <a:noFill/>
+          </a:ln>
+          <a:effectLst/>
+        </p:spPr>
+        <p:style>
+          <a:lnRef idx="1">
+            <a:schemeClr val="accent1"/>
+          </a:lnRef>
+          <a:fillRef idx="3">
+            <a:schemeClr val="accent1"/>
+          </a:fillRef>
+          <a:effectRef idx="2">
+            <a:schemeClr val="accent1"/>
+          </a:effectRef>
+          <a:fontRef idx="minor">
+            <a:schemeClr val="lt1"/>
+          </a:fontRef>
+        </p:style>
+        <p:txBody>
+          <a:bodyPr rtlCol="0" anchor="ctr"/>
+          <a:lstStyle/>
+          <a:p>
+            <a:pPr algn="ctr"/>
+          </a:p>
+        </p:txBody>
+      </p:sp>
+      <p:sp>
+        <p:nvSpPr>
+          <p:cNvPr id="21" name="TextBox 20"/>
+          <p:cNvSpPr txBox="1"/>
+          <p:nvPr/>
+        </p:nvSpPr>
+        <p:spPr>
+          <a:xfrm>
+            <a:off x="6492240" y="4517136"/>
+            <a:ext cx="5029200" cy="457200"/>
+          </a:xfrm>
+          <a:prstGeom prst="rect">
+            <a:avLst/>
+          </a:prstGeom>
+          <a:noFill/>
+        </p:spPr>
+        <p:txBody>
+          <a:bodyPr wrap="square" anchor="t" lIns="0" rIns="0" tIns="0" bIns="0">
+            <a:spAutoFit/>
+          </a:bodyPr>
+          <a:lstStyle/>
+          <a:p>
+            <a:pPr algn="l">
+              <a:defRPr sz="1300" b="1">
+                <a:solidFill>
+                  <a:srgbClr val="151515"/>
+                </a:solidFill>
+                <a:latin typeface="Arial"/>
+              </a:defRPr>
+            </a:pPr>
+            <a:r>
+              <a:t>Perímetro do Tipo 1</a:t>
+            </a:r>
+          </a:p>
+        </p:txBody>
+      </p:sp>
+      <p:sp>
+        <p:nvSpPr>
+          <p:cNvPr id="22" name="TextBox 21"/>
+          <p:cNvSpPr txBox="1"/>
+          <p:nvPr/>
+        </p:nvSpPr>
+        <p:spPr>
+          <a:xfrm>
+            <a:off x="6492240" y="4937759"/>
+            <a:ext cx="5029200" cy="868680"/>
+          </a:xfrm>
+          <a:prstGeom prst="rect">
+            <a:avLst/>
+          </a:prstGeom>
+          <a:noFill/>
+        </p:spPr>
+        <p:txBody>
+          <a:bodyPr wrap="square" anchor="t" lIns="0" rIns="0" tIns="0" bIns="0">
+            <a:spAutoFit/>
+          </a:bodyPr>
+          <a:lstStyle/>
+          <a:p>
+            <a:pPr algn="l">
+              <a:defRPr sz="1100" b="0">
+                <a:solidFill>
+                  <a:srgbClr val="5D6369"/>
+                </a:solidFill>
+                <a:latin typeface="Arial"/>
+              </a:defRPr>
+            </a:pPr>
+            <a:r>
+              <a:t>Debêntures simples, notas promissórias, notas comerciais, CPR-F e securitização (FIDC, CRI, CRA, CR). FII, FIAGRO e FIP-IE ficam nas operações híbridas e não entram.</a:t>
+            </a:r>
+          </a:p>
+        </p:txBody>
+      </p:sp>
+      <p:sp>
+        <p:nvSpPr>
+          <p:cNvPr id="23" name="Rectangle 22"/>
+          <p:cNvSpPr/>
+          <p:nvPr/>
+        </p:nvSpPr>
+        <p:spPr>
+          <a:xfrm>
+            <a:off x="566928" y="6355080"/>
+            <a:ext cx="11018520" cy="9144"/>
+          </a:xfrm>
+          <a:prstGeom prst="rect">
+            <a:avLst/>
+          </a:prstGeom>
+          <a:solidFill>
+            <a:srgbClr val="E7E9EB"/>
+          </a:solidFill>
+          <a:ln>
+            <a:noFill/>
+          </a:ln>
+        </p:spPr>
+        <p:style>
+          <a:lnRef idx="1">
+            <a:schemeClr val="accent1"/>
+          </a:lnRef>
+          <a:fillRef idx="3">
+            <a:schemeClr val="accent1"/>
+          </a:fillRef>
+          <a:effectRef idx="2">
+            <a:schemeClr val="accent1"/>
+          </a:effectRef>
+          <a:fontRef idx="minor">
+            <a:schemeClr val="lt1"/>
+          </a:fontRef>
+        </p:style>
+        <p:txBody>
+          <a:bodyPr rtlCol="0" anchor="ctr"/>
+          <a:lstStyle/>
+          <a:p>
+            <a:pPr algn="ctr"/>
+          </a:p>
+        </p:txBody>
+      </p:sp>
+      <p:sp>
+        <p:nvSpPr>
+          <p:cNvPr id="24" name="TextBox 23"/>
+          <p:cNvSpPr txBox="1"/>
+          <p:nvPr/>
+        </p:nvSpPr>
+        <p:spPr>
+          <a:xfrm>
+            <a:off x="566928" y="6419088"/>
+            <a:ext cx="10469880" cy="274320"/>
+          </a:xfrm>
+          <a:prstGeom prst="rect">
+            <a:avLst/>
+          </a:prstGeom>
+          <a:noFill/>
+        </p:spPr>
+        <p:txBody>
+          <a:bodyPr wrap="square" anchor="t" lIns="0" rIns="0" tIns="0" bIns="0">
+            <a:spAutoFit/>
+          </a:bodyPr>
+          <a:lstStyle/>
+          <a:p>
+            <a:pPr algn="l">
+              <a:defRPr sz="800" b="0">
+                <a:solidFill>
+                  <a:srgbClr val="8D9399"/>
+                </a:solidFill>
+                <a:latin typeface="Arial"/>
+              </a:defRPr>
+            </a:pPr>
+            <a:r>
+              <a:t>Fonte: ANBIMA, Metodologia do Ranking de Renda Fixa e Híbridos (fev/2026), capítulos II a VII</a:t>
+            </a:r>
+          </a:p>
+        </p:txBody>
+      </p:sp>
+      <p:sp>
+        <p:nvSpPr>
+          <p:cNvPr id="25" name="TextBox 24"/>
+          <p:cNvSpPr txBox="1"/>
+          <p:nvPr/>
+        </p:nvSpPr>
+        <p:spPr>
+          <a:xfrm>
+            <a:off x="11201400" y="6409944"/>
+            <a:ext cx="384048" cy="201168"/>
+          </a:xfrm>
+          <a:prstGeom prst="rect">
+            <a:avLst/>
+          </a:prstGeom>
+          <a:noFill/>
+        </p:spPr>
+        <p:txBody>
+          <a:bodyPr wrap="square" anchor="t" lIns="0" rIns="0" tIns="0" bIns="0">
+            <a:spAutoFit/>
+          </a:bodyPr>
+          <a:lstStyle/>
+          <a:p>
+            <a:pPr algn="r">
+              <a:defRPr sz="800" b="0">
+                <a:solidFill>
+                  <a:srgbClr val="8D9399"/>
+                </a:solidFill>
+                <a:latin typeface="Arial"/>
+              </a:defRPr>
+            </a:pPr>
+            <a:r>
+              <a:t>4</a:t>
+            </a:r>
+          </a:p>
+        </p:txBody>
+      </p:sp>
+    </p:spTree>
+  </p:cSld>
+  <p:clrMapOvr>
+    <a:masterClrMapping/>
+  </p:clrMapOvr>
+</p:sld>
+</file>
+
+<file path=ppt/slides/slide6.xml><?xml version="1.0" encoding="utf-8"?>
+<p:sld xmlns:a="http://schemas.openxmlformats.org/drawingml/2006/main" xmlns:p="http://schemas.openxmlformats.org/presentationml/2006/main" xmlns:r="http://schemas.openxmlformats.org/officeDocument/2006/relationships">
+  <p:cSld>
+    <p:bg>
+      <p:bgPr>
+        <a:solidFill>
+          <a:srgbClr val="FFFFFF"/>
+        </a:solidFill>
+        <a:effectLst/>
+      </p:bgPr>
+    </p:bg>
+    <p:spTree>
+      <p:nvGrpSpPr>
+        <p:cNvPr id="1" name=""/>
+        <p:cNvGrpSpPr/>
+        <p:nvPr/>
+      </p:nvGrpSpPr>
+      <p:grpSpPr/>
+      <p:sp>
+        <p:nvSpPr>
+          <p:cNvPr id="2" name="TextBox 1"/>
+          <p:cNvSpPr txBox="1"/>
+          <p:nvPr/>
+        </p:nvSpPr>
+        <p:spPr>
+          <a:xfrm>
+            <a:off x="566928" y="256032"/>
+            <a:ext cx="7315200" cy="201168"/>
           </a:xfrm>
           <a:prstGeom prst="rect">
             <a:avLst/>
@@ -9297,27 +12314,27 @@
             <a:pPr algn="l">
               <a:defRPr sz="1000" b="1">
                 <a:solidFill>
-                  <a:srgbClr val="8D9399"/>
-                </a:solidFill>
-                <a:latin typeface="Arial"/>
-              </a:defRPr>
-            </a:pPr>
-            <a:r>
-              <a:t>Insumo</a:t>
-            </a:r>
-          </a:p>
-        </p:txBody>
-      </p:sp>
-      <p:sp>
-        <p:nvSpPr>
-          <p:cNvPr id="6" name="TextBox 5"/>
-          <p:cNvSpPr txBox="1"/>
-          <p:nvPr/>
-        </p:nvSpPr>
-        <p:spPr>
-          <a:xfrm>
-            <a:off x="3401568" y="1371600"/>
-            <a:ext cx="5852160" cy="347472"/>
+                  <a:srgbClr val="E36C0A"/>
+                </a:solidFill>
+                <a:latin typeface="Arial"/>
+              </a:defRPr>
+            </a:pPr>
+            <a:r>
+              <a:t>RANKING ANBIMA · RENDA FIXA</a:t>
+            </a:r>
+          </a:p>
+        </p:txBody>
+      </p:sp>
+      <p:sp>
+        <p:nvSpPr>
+          <p:cNvPr id="3" name="TextBox 2"/>
+          <p:cNvSpPr txBox="1"/>
+          <p:nvPr/>
+        </p:nvSpPr>
+        <p:spPr>
+          <a:xfrm>
+            <a:off x="566928" y="521207"/>
+            <a:ext cx="11064240" cy="438912"/>
           </a:xfrm>
           <a:prstGeom prst="rect">
             <a:avLst/>
@@ -9331,65 +12348,29 @@
           <a:lstStyle/>
           <a:p>
             <a:pPr algn="l">
-              <a:defRPr sz="1000" b="1">
-                <a:solidFill>
-                  <a:srgbClr val="8D9399"/>
-                </a:solidFill>
-                <a:latin typeface="Arial"/>
-              </a:defRPr>
-            </a:pPr>
-            <a:r>
-              <a:t>Arquivo</a:t>
-            </a:r>
-          </a:p>
-        </p:txBody>
-      </p:sp>
-      <p:sp>
-        <p:nvSpPr>
-          <p:cNvPr id="7" name="TextBox 6"/>
-          <p:cNvSpPr txBox="1"/>
-          <p:nvPr/>
-        </p:nvSpPr>
-        <p:spPr>
-          <a:xfrm>
-            <a:off x="9253728" y="1371600"/>
-            <a:ext cx="2286000" cy="347472"/>
-          </a:xfrm>
-          <a:prstGeom prst="rect">
-            <a:avLst/>
-          </a:prstGeom>
-          <a:noFill/>
-        </p:spPr>
-        <p:txBody>
-          <a:bodyPr wrap="square" anchor="t" lIns="0" rIns="0" tIns="0" bIns="0">
-            <a:spAutoFit/>
-          </a:bodyPr>
-          <a:lstStyle/>
-          <a:p>
-            <a:pPr algn="l">
-              <a:defRPr sz="1000" b="1">
-                <a:solidFill>
-                  <a:srgbClr val="8D9399"/>
-                </a:solidFill>
-                <a:latin typeface="Arial"/>
-              </a:defRPr>
-            </a:pPr>
-            <a:r>
-              <a:t>SHA-256 (12)</a:t>
-            </a:r>
-          </a:p>
-        </p:txBody>
-      </p:sp>
-      <p:sp>
-        <p:nvSpPr>
-          <p:cNvPr id="8" name="Rectangle 7"/>
+              <a:defRPr sz="2200" b="1">
+                <a:solidFill>
+                  <a:srgbClr val="151515"/>
+                </a:solidFill>
+                <a:latin typeface="Arial"/>
+              </a:defRPr>
+            </a:pPr>
+            <a:r>
+              <a:t>Fontes, reprodutibilidade e ressalvas</a:t>
+            </a:r>
+          </a:p>
+        </p:txBody>
+      </p:sp>
+      <p:sp>
+        <p:nvSpPr>
+          <p:cNvPr id="4" name="Rectangle 3"/>
           <p:cNvSpPr/>
           <p:nvPr/>
         </p:nvSpPr>
         <p:spPr>
           <a:xfrm>
-            <a:off x="566928" y="1666951"/>
-            <a:ext cx="10972800" cy="10972"/>
+            <a:off x="566928" y="1051560"/>
+            <a:ext cx="11018520" cy="16459"/>
           </a:xfrm>
           <a:prstGeom prst="rect">
             <a:avLst/>
@@ -9425,6 +12406,157 @@
       </p:sp>
       <p:sp>
         <p:nvSpPr>
+          <p:cNvPr id="5" name="TextBox 4"/>
+          <p:cNvSpPr txBox="1"/>
+          <p:nvPr/>
+        </p:nvSpPr>
+        <p:spPr>
+          <a:xfrm>
+            <a:off x="566928" y="1371600"/>
+            <a:ext cx="2834640" cy="347472"/>
+          </a:xfrm>
+          <a:prstGeom prst="rect">
+            <a:avLst/>
+          </a:prstGeom>
+          <a:noFill/>
+        </p:spPr>
+        <p:txBody>
+          <a:bodyPr wrap="square" anchor="t" lIns="0" rIns="0" tIns="0" bIns="0">
+            <a:spAutoFit/>
+          </a:bodyPr>
+          <a:lstStyle/>
+          <a:p>
+            <a:pPr algn="l">
+              <a:defRPr sz="1000" b="1">
+                <a:solidFill>
+                  <a:srgbClr val="8D9399"/>
+                </a:solidFill>
+                <a:latin typeface="Arial"/>
+              </a:defRPr>
+            </a:pPr>
+            <a:r>
+              <a:t>Insumo</a:t>
+            </a:r>
+          </a:p>
+        </p:txBody>
+      </p:sp>
+      <p:sp>
+        <p:nvSpPr>
+          <p:cNvPr id="6" name="TextBox 5"/>
+          <p:cNvSpPr txBox="1"/>
+          <p:nvPr/>
+        </p:nvSpPr>
+        <p:spPr>
+          <a:xfrm>
+            <a:off x="3401568" y="1371600"/>
+            <a:ext cx="5852160" cy="347472"/>
+          </a:xfrm>
+          <a:prstGeom prst="rect">
+            <a:avLst/>
+          </a:prstGeom>
+          <a:noFill/>
+        </p:spPr>
+        <p:txBody>
+          <a:bodyPr wrap="square" anchor="t" lIns="0" rIns="0" tIns="0" bIns="0">
+            <a:spAutoFit/>
+          </a:bodyPr>
+          <a:lstStyle/>
+          <a:p>
+            <a:pPr algn="l">
+              <a:defRPr sz="1000" b="1">
+                <a:solidFill>
+                  <a:srgbClr val="8D9399"/>
+                </a:solidFill>
+                <a:latin typeface="Arial"/>
+              </a:defRPr>
+            </a:pPr>
+            <a:r>
+              <a:t>Arquivo</a:t>
+            </a:r>
+          </a:p>
+        </p:txBody>
+      </p:sp>
+      <p:sp>
+        <p:nvSpPr>
+          <p:cNvPr id="7" name="TextBox 6"/>
+          <p:cNvSpPr txBox="1"/>
+          <p:nvPr/>
+        </p:nvSpPr>
+        <p:spPr>
+          <a:xfrm>
+            <a:off x="9253728" y="1371600"/>
+            <a:ext cx="2286000" cy="347472"/>
+          </a:xfrm>
+          <a:prstGeom prst="rect">
+            <a:avLst/>
+          </a:prstGeom>
+          <a:noFill/>
+        </p:spPr>
+        <p:txBody>
+          <a:bodyPr wrap="square" anchor="t" lIns="0" rIns="0" tIns="0" bIns="0">
+            <a:spAutoFit/>
+          </a:bodyPr>
+          <a:lstStyle/>
+          <a:p>
+            <a:pPr algn="l">
+              <a:defRPr sz="1000" b="1">
+                <a:solidFill>
+                  <a:srgbClr val="8D9399"/>
+                </a:solidFill>
+                <a:latin typeface="Arial"/>
+              </a:defRPr>
+            </a:pPr>
+            <a:r>
+              <a:t>SHA-256 (12)</a:t>
+            </a:r>
+          </a:p>
+        </p:txBody>
+      </p:sp>
+      <p:sp>
+        <p:nvSpPr>
+          <p:cNvPr id="8" name="Rectangle 7"/>
+          <p:cNvSpPr/>
+          <p:nvPr/>
+        </p:nvSpPr>
+        <p:spPr>
+          <a:xfrm>
+            <a:off x="566928" y="1666951"/>
+            <a:ext cx="10972800" cy="10972"/>
+          </a:xfrm>
+          <a:prstGeom prst="rect">
+            <a:avLst/>
+          </a:prstGeom>
+          <a:solidFill>
+            <a:srgbClr val="D7DADD"/>
+          </a:solidFill>
+          <a:ln>
+            <a:noFill/>
+          </a:ln>
+        </p:spPr>
+        <p:style>
+          <a:lnRef idx="1">
+            <a:schemeClr val="accent1"/>
+          </a:lnRef>
+          <a:fillRef idx="3">
+            <a:schemeClr val="accent1"/>
+          </a:fillRef>
+          <a:effectRef idx="2">
+            <a:schemeClr val="accent1"/>
+          </a:effectRef>
+          <a:fontRef idx="minor">
+            <a:schemeClr val="lt1"/>
+          </a:fontRef>
+        </p:style>
+        <p:txBody>
+          <a:bodyPr rtlCol="0" anchor="ctr"/>
+          <a:lstStyle/>
+          <a:p>
+            <a:pPr algn="ctr"/>
+          </a:p>
+        </p:txBody>
+      </p:sp>
+      <p:sp>
+        <p:nvSpPr>
           <p:cNvPr id="9" name="TextBox 8"/>
           <p:cNvSpPr txBox="1"/>
           <p:nvPr/>
@@ -10159,7 +13291,7 @@
               </a:defRPr>
             </a:pPr>
             <a:r>
-              <a:t>4</a:t>
+              <a:t>5</a:t>
             </a:r>
           </a:p>
         </p:txBody>

</xml_diff>